<commit_message>
Om deck: tile drawn as tensors (input window, filters, 80-output strip), term definitions slide
Co-Authored-By: Claude Opus 5.5 <noreply@anthropic.com>
Claude-Session: https://claude.ai/code/session_01AeVaHM9UcLNRWUmMTDhqz2
</commit_message>
<xml_diff>
--- a/docs/milestone/om/slides/om_mid_presentation.pptx
+++ b/docs/milestone/om/slides/om_mid_presentation.pptx
@@ -11,9 +11,10 @@
     <p:sldId id="259" r:id="rId5"/>
     <p:sldId id="260" r:id="rId6"/>
     <p:sldId id="261" r:id="rId7"/>
+    <p:sldId id="262" r:id="rId8"/>
   </p:sldIdLst>
   <p:notesMasterIdLst>
-    <p:notesMasterId r:id="rId8"/>
+    <p:notesMasterId r:id="rId9"/>
   </p:notesMasterIdLst>
   <p:sldSz cx="9144000" cy="5143500"/>
   <p:notesSz cx="5143500" cy="9144000"/>
@@ -112,22 +113,23 @@
   <p:extLst>
     <p:ext uri="{521415D9-36F7-43E2-AB2F-B90AF26B5E84}">
       <p14:sectionLst xmlns:p14="http://schemas.microsoft.com/office/powerpoint/2010/main">
-        <p14:section name="Intro" id="{c99a2e22-a893-3e03-72cd-d2bbd301c1ea}">
+        <p14:section name="Intro" id="{cc0f6be9-b7b3-fc0e-4545-2378d9700c8e}">
           <p14:sldIdLst>
             <p14:sldId id="256"/>
           </p14:sldIdLst>
         </p14:section>
-        <p14:section name="Method" id="{b7700f03-235e-a8ea-41c7-8560590ddc8f}">
+        <p14:section name="Method" id="{c5a1c77a-29a8-b51b-7f16-31a5da34ae49}">
           <p14:sldIdLst>
             <p14:sldId id="257"/>
             <p14:sldId id="258"/>
+            <p14:sldId id="259"/>
           </p14:sldIdLst>
         </p14:section>
-        <p14:section name="Results" id="{a866fd3f-6a4f-2039-51dc-c07e4d532ae0}">
+        <p14:section name="Results" id="{7b78a160-273f-887b-f5da-1e61c89234f7}">
           <p14:sldIdLst>
-            <p14:sldId id="259"/>
             <p14:sldId id="260"/>
             <p14:sldId id="261"/>
+            <p14:sldId id="262"/>
           </p14:sldIdLst>
         </p14:section>
       </p14:sectionLst>
@@ -1215,7 +1217,7 @@
           <a:p>
             <a:r>
               <a:rPr lang="en-US" dirty="0"/>
-              <a:t>Same machine as Assignment 2 and the same kernel. In A2, m was 5 rows of A broadcast, n was 8 doubles = 2 vectors of B. Here m is 5 output pixels, n is 16 output channels = 2 vectors of 8 floats, and k is input channels times the 9 taps of the 3x3 filter. 10 accumulators, 13 registers, exactly the A2 budget. Peak is 32 FLOPs per cycle because floats give 8 lanes instead of 4.</a:t>
+              <a:t>Same machine as Assignment 2 and the same kernel. In A2, m was 5 rows of A broadcast, n was 8 doubles = 2 vectors of B. Here m is 5 output pixels, n is 16 output channels = 2 vectors of 8 floats, and k is input channels times the 9 taps of the 3x3 filter. 10 accumulators, 13 registers, exactly the A2 budget. Peak is 32 FLOPs per cycle because floats give 8 lanes instead of 4. Terms: C is input channels; k = C x 9 is the length of each output's sum; an accumulator is one register holding 8 outputs; the tile is the block of outputs one call computes.</a:t>
             </a:r>
             <a:endParaRPr lang="en-US" dirty="0"/>
           </a:p>
@@ -1303,7 +1305,7 @@
           <a:p>
             <a:r>
               <a:rPr lang="en-US" dirty="0"/>
-              <a:t>Step 1: every output is an independent dot product, so there is plenty of parallelism; the only chain is the reduction. Step 2: 5-cycle latency times 2 FMAs per cycle means 10 independent accumulators. The chart shows it: 1 accumulator is 10%, each one adds about 10 points. Step 3: 2x5 gives 10 accumulators in 13 registers, 7 loads per 10 FMAs, and 5 divides 160, 80, 40 and 20. Step 4: benchmark the kernel alone exactly like Assignment 2.</a:t>
+              <a:t>One call of the microkernel computes this teal strip: one output row, 5 pixels wide, 16 output channels deep, 80 numbers. Each cell is 8 channels of one pixel, which is exactly one YMM register, so the strip is 10 accumulators. To compute it, the kernel reads a 3 by 7 window of the input across all C channels and 16 filters of 3 by 3 by C. Each step multiplies 2 weight vectors by 5 broadcast inputs, 10 FMAs, and it repeats that k = C times 9 times before applying bias and SiLU and storing.</a:t>
             </a:r>
             <a:endParaRPr lang="en-US" dirty="0"/>
           </a:p>
@@ -1391,7 +1393,7 @@
           <a:p>
             <a:r>
               <a:rPr lang="en-US" dirty="0"/>
-              <a:t>Every kernel I built, same arithmetic, same layout. Filled dots are the microkernel alone, hollow are all 32 layers. Left: the accumulator count. Right: the 2x6 tile my teammates suggested loses with intrinsics because GCC adds 11 register copies per tap at 15 live registers, but with the registers fixed in inline asm it is the best kernel, 94.5% alone. 4x3 needs all 16 registers; GCC spills it to 49%. The lecture techniques, unrolling and software pipelining, made it worse: full unrolling overflowed the uop cache and partial unrolling made GCC spill.</a:t>
+              <a:t>Step 1: every output is an independent dot product, so there is plenty of parallelism; the only chain is the reduction. Step 2: 5-cycle latency times 2 FMAs per cycle means 10 independent accumulators. The chart shows it: 1 accumulator is 10%, each one adds about 10 points. Step 3: 2x5 gives 10 accumulators in 13 registers, 7 loads per 10 FMAs, and 5 divides 160, 80, 40 and 20. Step 4: benchmark the kernel alone exactly like Assignment 2.</a:t>
             </a:r>
             <a:endParaRPr lang="en-US" dirty="0"/>
           </a:p>
@@ -1479,7 +1481,7 @@
           <a:p>
             <a:r>
               <a:rPr lang="en-US" dirty="0"/>
-              <a:t>This is the Assignment 2 figure for my kernel: FLOPs per cycle against the reduction length k. 2x6 asm holds 30 to 31 FLOPs per cycle, 94 to 98 percent of peak. 2x5 intrinsics is 85 to 90. The dip near k = 500 is the 2x5 weights leaving L1, the same effect as k = 315 in A2. Cross-checked: the hardware FP-instruction counter matches our FLOP count exactly, and cycles over wall time gives 3.2 GHz.</a:t>
+              <a:t>Every kernel I built, same arithmetic, same layout. Filled dots are the microkernel alone, hollow are all 32 layers. Left: the accumulator count. Right: the 2x6 tile my teammates suggested loses with intrinsics because GCC adds 11 register copies per tap at 15 live registers, but with the registers fixed in inline asm it is the best kernel, 94.5% alone. 4x3 needs all 16 registers; GCC spills it to 49%. The lecture techniques, unrolling and software pipelining, made it worse: full unrolling overflowed the uop cache and partial unrolling made GCC spill.</a:t>
             </a:r>
             <a:endParaRPr lang="en-US" dirty="0"/>
           </a:p>
@@ -1567,7 +1569,7 @@
           <a:p>
             <a:r>
               <a:rPr lang="en-US" dirty="0"/>
-              <a:t>Kernel A, 2x5 in asm, beat kernel B, 2x5 intrinsics, by 6 points alone but lost by 3.5 in the layers. The assembly shows why: inlined into the layer loop, GCC keeps 3 accumulators on the stack and reloads them around every tap. Calling the microkernel as a function, exactly as the benchmark does, fixes it: 83.4% for 2x5 and 84.1% for v10. v10 is 1.36 times faster than OpenCV and within 2% of ONNX Runtime on all 32 layers. Next: cache blocking and threading.</a:t>
+              <a:t>This is the Assignment 2 figure for my kernel: FLOPs per cycle against the reduction length k. 2x6 asm holds 30 to 31 FLOPs per cycle, 94 to 98 percent of peak. 2x5 intrinsics is 85 to 90. The dip near k = 500 is the 2x5 weights leaving L1, the same effect as k = 315 in A2. Cross-checked: the hardware FP-instruction counter matches our FLOP count exactly, and cycles over wall time gives 3.2 GHz.</a:t>
             </a:r>
             <a:endParaRPr lang="en-US" dirty="0"/>
           </a:p>
@@ -1591,6 +1593,94 @@
             <a:fld id="{F7021451-1387-4CA6-816F-3879F97B5CBC}" type="slidenum">
               <a:rPr lang="en-US"/>
               <a:t>6</a:t>
+            </a:fld>
+            <a:endParaRPr lang="en-US"/>
+          </a:p>
+        </p:txBody>
+      </p:sp>
+    </p:spTree>
+    <p:extLst>
+      <p:ext uri="{BB962C8B-B14F-4D97-AF65-F5344CB8AC3E}">
+        <p14:creationId xmlns:p14="http://schemas.microsoft.com/office/powerpoint/2010/main" val="1024086991"/>
+      </p:ext>
+    </p:extLst>
+  </p:cSld>
+  <p:clrMapOvr>
+    <a:masterClrMapping/>
+  </p:clrMapOvr>
+</p:notes>
+</file>
+
+<file path=ppt/notesSlides/notesSlide7.xml><?xml version="1.0" encoding="utf-8"?>
+<p:notes xmlns:a="http://schemas.openxmlformats.org/drawingml/2006/main" xmlns:r="http://schemas.openxmlformats.org/officeDocument/2006/relationships" xmlns:p="http://schemas.openxmlformats.org/presentationml/2006/main">
+  <p:cSld>
+    <p:spTree>
+      <p:nvGrpSpPr>
+        <p:cNvPr id="1" name=""/>
+        <p:cNvGrpSpPr/>
+        <p:nvPr/>
+      </p:nvGrpSpPr>
+      <p:grpSpPr>
+        <a:xfrm>
+          <a:off x="0" y="0"/>
+          <a:ext cx="0" cy="0"/>
+          <a:chOff x="0" y="0"/>
+          <a:chExt cx="0" cy="0"/>
+        </a:xfrm>
+      </p:grpSpPr>
+      <p:sp>
+        <p:nvSpPr>
+          <p:cNvPr id="2" name="Slide Image Placeholder 1"/>
+          <p:cNvSpPr>
+            <a:spLocks noGrp="1" noRot="1" noChangeAspect="1"/>
+          </p:cNvSpPr>
+          <p:nvPr>
+            <p:ph type="sldImg"/>
+          </p:nvPr>
+        </p:nvSpPr>
+        <p:spPr/>
+      </p:sp>
+      <p:sp>
+        <p:nvSpPr>
+          <p:cNvPr id="3" name="Notes Placeholder 2"/>
+          <p:cNvSpPr>
+            <a:spLocks noGrp="1"/>
+          </p:cNvSpPr>
+          <p:nvPr>
+            <p:ph type="body" idx="1"/>
+          </p:nvPr>
+        </p:nvSpPr>
+        <p:spPr/>
+        <p:txBody>
+          <a:bodyPr/>
+          <a:lstStyle/>
+          <a:p>
+            <a:r>
+              <a:rPr lang="en-US" dirty="0"/>
+              <a:t>Kernel A, 2x5 in asm, beat kernel B, 2x5 intrinsics, by 6 points alone but lost by 3.5 in the layers. The assembly shows why: inlined into the layer loop, GCC keeps 3 accumulators on the stack and reloads them around every tap. Calling the microkernel as a function, exactly as the benchmark does, fixes it: 83.4% for 2x5 and 84.1% for v10. v10 is 1.36 times faster than OpenCV and within 2% of ONNX Runtime on all 32 layers. Next: cache blocking and threading.</a:t>
+            </a:r>
+            <a:endParaRPr lang="en-US" dirty="0"/>
+          </a:p>
+        </p:txBody>
+      </p:sp>
+      <p:sp>
+        <p:nvSpPr>
+          <p:cNvPr id="4" name="Slide Number Placeholder 3"/>
+          <p:cNvSpPr>
+            <a:spLocks noGrp="1"/>
+          </p:cNvSpPr>
+          <p:nvPr>
+            <p:ph type="sldNum" sz="quarter" idx="10"/>
+          </p:nvPr>
+        </p:nvSpPr>
+        <p:spPr/>
+        <p:txBody>
+          <a:bodyPr/>
+          <a:lstStyle/>
+          <a:p>
+            <a:fld id="{F7021451-1387-4CA6-816F-3879F97B5CBC}" type="slidenum">
+              <a:rPr lang="en-US"/>
+              <a:t>7</a:t>
             </a:fld>
             <a:endParaRPr lang="en-US"/>
           </a:p>
@@ -4127,14 +4217,41 @@
       </p:sp>
       <p:sp>
         <p:nvSpPr>
-          <p:cNvPr id="5" name="Text 2"/>
+          <p:cNvPr id="5" name="term-0"/>
+          <p:cNvSpPr/>
+          <p:nvPr/>
+        </p:nvSpPr>
+        <p:spPr>
+          <a:xfrm>
+            <a:off x="5166360" y="1097280"/>
+            <a:ext cx="3566160" cy="777240"/>
+          </a:xfrm>
+          <a:prstGeom prst="roundRect">
+            <a:avLst>
+              <a:gd name="adj" fmla="val 9412"/>
+            </a:avLst>
+          </a:prstGeom>
+          <a:solidFill>
+            <a:srgbClr val="EEF2F4"/>
+          </a:solidFill>
+          <a:ln w="12700">
+            <a:solidFill>
+              <a:srgbClr val="EEF2F4"/>
+            </a:solidFill>
+            <a:prstDash val="solid"/>
+          </a:ln>
+        </p:spPr>
+      </p:sp>
+      <p:sp>
+        <p:nvSpPr>
+          <p:cNvPr id="6" name="Text 3"/>
           <p:cNvSpPr txBox="1"/>
           <p:nvPr/>
         </p:nvSpPr>
         <p:spPr>
           <a:xfrm>
-            <a:off x="5166360" y="1051560"/>
-            <a:ext cx="3566160" cy="274320"/>
+            <a:off x="5303520" y="1170432"/>
+            <a:ext cx="3337560" cy="256032"/>
           </a:xfrm>
           <a:prstGeom prst="rect">
             <a:avLst/>
@@ -4150,70 +4267,7 @@
               <a:buNone/>
             </a:pPr>
             <a:r>
-              <a:rPr lang="en-US" sz="1200" dirty="0">
-                <a:solidFill>
-                  <a:schemeClr val="tx2"/>
-                </a:solidFill>
-              </a:rPr>
-              <a:t>one step: 5 broadcasts × 2 weight vectors</a:t>
-            </a:r>
-            <a:endParaRPr lang="en-US" sz="1200" dirty="0"/>
-          </a:p>
-        </p:txBody>
-      </p:sp>
-      <p:sp>
-        <p:nvSpPr>
-          <p:cNvPr id="6" name="bcast-0"/>
-          <p:cNvSpPr/>
-          <p:nvPr/>
-        </p:nvSpPr>
-        <p:spPr>
-          <a:xfrm>
-            <a:off x="5897880" y="1298448"/>
-            <a:ext cx="548640" cy="237744"/>
-          </a:xfrm>
-          <a:prstGeom prst="roundRect">
-            <a:avLst>
-              <a:gd name="adj" fmla="val 15385"/>
-            </a:avLst>
-          </a:prstGeom>
-          <a:solidFill>
-            <a:srgbClr val="FFFFFF"/>
-          </a:solidFill>
-          <a:ln w="12700">
-            <a:solidFill>
-              <a:srgbClr val="1B2630"/>
-            </a:solidFill>
-            <a:prstDash val="solid"/>
-          </a:ln>
-        </p:spPr>
-      </p:sp>
-      <p:sp>
-        <p:nvSpPr>
-          <p:cNvPr id="7" name="Text 4"/>
-          <p:cNvSpPr txBox="1"/>
-          <p:nvPr/>
-        </p:nvSpPr>
-        <p:spPr>
-          <a:xfrm>
-            <a:off x="5897880" y="1298448"/>
-            <a:ext cx="548640" cy="237744"/>
-          </a:xfrm>
-          <a:prstGeom prst="rect">
-            <a:avLst/>
-          </a:prstGeom>
-          <a:noFill/>
-          <a:ln/>
-        </p:spPr>
-        <p:txBody>
-          <a:bodyPr wrap="square" lIns="0" tIns="0" rIns="0" bIns="0" rtlCol="0" anchor="ctr"/>
-          <a:lstStyle/>
-          <a:p>
-            <a:pPr algn="ctr" indent="0" marL="0">
-              <a:buNone/>
-            </a:pPr>
-            <a:r>
-              <a:rPr lang="en-US" sz="1100" dirty="0">
+              <a:rPr lang="en-US" sz="1300" b="1" dirty="0">
                 <a:solidFill>
                   <a:schemeClr val="tx1"/>
                 </a:solidFill>
@@ -4221,7 +4275,43 @@
                 <a:ea typeface="Courier New" pitchFamily="34" charset="-122"/>
                 <a:cs typeface="Courier New" pitchFamily="34" charset="-120"/>
               </a:rPr>
-              <a:t>x0</a:t>
+              <a:t>C</a:t>
+            </a:r>
+            <a:endParaRPr lang="en-US" sz="1300" dirty="0"/>
+          </a:p>
+        </p:txBody>
+      </p:sp>
+      <p:sp>
+        <p:nvSpPr>
+          <p:cNvPr id="7" name="Text 4"/>
+          <p:cNvSpPr txBox="1"/>
+          <p:nvPr/>
+        </p:nvSpPr>
+        <p:spPr>
+          <a:xfrm>
+            <a:off x="5303520" y="1444752"/>
+            <a:ext cx="3337560" cy="411480"/>
+          </a:xfrm>
+          <a:prstGeom prst="rect">
+            <a:avLst/>
+          </a:prstGeom>
+          <a:noFill/>
+          <a:ln/>
+        </p:spPr>
+        <p:txBody>
+          <a:bodyPr wrap="square" lIns="0" tIns="0" rIns="0" bIns="0" rtlCol="0" anchor="t"/>
+          <a:lstStyle/>
+          <a:p>
+            <a:pPr indent="0" marL="0">
+              <a:buNone/>
+            </a:pPr>
+            <a:r>
+              <a:rPr lang="en-US" sz="1100" dirty="0">
+                <a:solidFill>
+                  <a:schemeClr val="tx2"/>
+                </a:solidFill>
+              </a:rPr>
+              <a:t>input channels of the layer (16 to 256)</a:t>
             </a:r>
             <a:endParaRPr lang="en-US" sz="1100" dirty="0"/>
           </a:p>
@@ -4229,26 +4319,26 @@
       </p:sp>
       <p:sp>
         <p:nvSpPr>
-          <p:cNvPr id="8" name="bcast-1"/>
+          <p:cNvPr id="8" name="term-1"/>
           <p:cNvSpPr/>
           <p:nvPr/>
         </p:nvSpPr>
         <p:spPr>
           <a:xfrm>
-            <a:off x="6501384" y="1298448"/>
-            <a:ext cx="548640" cy="237744"/>
+            <a:off x="5166360" y="1965960"/>
+            <a:ext cx="3566160" cy="777240"/>
           </a:xfrm>
           <a:prstGeom prst="roundRect">
             <a:avLst>
-              <a:gd name="adj" fmla="val 15385"/>
+              <a:gd name="adj" fmla="val 9412"/>
             </a:avLst>
           </a:prstGeom>
           <a:solidFill>
-            <a:srgbClr val="FFFFFF"/>
+            <a:srgbClr val="EEF2F4"/>
           </a:solidFill>
           <a:ln w="12700">
             <a:solidFill>
-              <a:srgbClr val="1B2630"/>
+              <a:srgbClr val="EEF2F4"/>
             </a:solidFill>
             <a:prstDash val="solid"/>
           </a:ln>
@@ -4262,8 +4352,8 @@
         </p:nvSpPr>
         <p:spPr>
           <a:xfrm>
-            <a:off x="6501384" y="1298448"/>
-            <a:ext cx="548640" cy="237744"/>
+            <a:off x="5303520" y="2039112"/>
+            <a:ext cx="3337560" cy="256032"/>
           </a:xfrm>
           <a:prstGeom prst="rect">
             <a:avLst/>
@@ -4272,14 +4362,14 @@
           <a:ln/>
         </p:spPr>
         <p:txBody>
-          <a:bodyPr wrap="square" lIns="0" tIns="0" rIns="0" bIns="0" rtlCol="0" anchor="ctr"/>
-          <a:lstStyle/>
-          <a:p>
-            <a:pPr algn="ctr" indent="0" marL="0">
+          <a:bodyPr wrap="square" lIns="0" tIns="0" rIns="0" bIns="0" rtlCol="0" anchor="t"/>
+          <a:lstStyle/>
+          <a:p>
+            <a:pPr indent="0" marL="0">
               <a:buNone/>
             </a:pPr>
             <a:r>
-              <a:rPr lang="en-US" sz="1100" dirty="0">
+              <a:rPr lang="en-US" sz="1300" b="1" dirty="0">
                 <a:solidFill>
                   <a:schemeClr val="tx1"/>
                 </a:solidFill>
@@ -4287,7 +4377,43 @@
                 <a:ea typeface="Courier New" pitchFamily="34" charset="-122"/>
                 <a:cs typeface="Courier New" pitchFamily="34" charset="-120"/>
               </a:rPr>
-              <a:t>x1</a:t>
+              <a:t>k = C × 9</a:t>
+            </a:r>
+            <a:endParaRPr lang="en-US" sz="1300" dirty="0"/>
+          </a:p>
+        </p:txBody>
+      </p:sp>
+      <p:sp>
+        <p:nvSpPr>
+          <p:cNvPr id="10" name="Text 7"/>
+          <p:cNvSpPr txBox="1"/>
+          <p:nvPr/>
+        </p:nvSpPr>
+        <p:spPr>
+          <a:xfrm>
+            <a:off x="5303520" y="2313432"/>
+            <a:ext cx="3337560" cy="411480"/>
+          </a:xfrm>
+          <a:prstGeom prst="rect">
+            <a:avLst/>
+          </a:prstGeom>
+          <a:noFill/>
+          <a:ln/>
+        </p:spPr>
+        <p:txBody>
+          <a:bodyPr wrap="square" lIns="0" tIns="0" rIns="0" bIns="0" rtlCol="0" anchor="t"/>
+          <a:lstStyle/>
+          <a:p>
+            <a:pPr indent="0" marL="0">
+              <a:buNone/>
+            </a:pPr>
+            <a:r>
+              <a:rPr lang="en-US" sz="1100" dirty="0">
+                <a:solidFill>
+                  <a:schemeClr val="tx2"/>
+                </a:solidFill>
+              </a:rPr>
+              <a:t>multiply-adds per output: C channels × the 9 taps of the 3×3 filter (A2's k)</a:t>
             </a:r>
             <a:endParaRPr lang="en-US" sz="1100" dirty="0"/>
           </a:p>
@@ -4295,26 +4421,26 @@
       </p:sp>
       <p:sp>
         <p:nvSpPr>
-          <p:cNvPr id="10" name="bcast-2"/>
+          <p:cNvPr id="11" name="term-2"/>
           <p:cNvSpPr/>
           <p:nvPr/>
         </p:nvSpPr>
         <p:spPr>
           <a:xfrm>
-            <a:off x="7104888" y="1298448"/>
-            <a:ext cx="548640" cy="237744"/>
+            <a:off x="5166360" y="2834640"/>
+            <a:ext cx="3566160" cy="777240"/>
           </a:xfrm>
           <a:prstGeom prst="roundRect">
             <a:avLst>
-              <a:gd name="adj" fmla="val 15385"/>
+              <a:gd name="adj" fmla="val 9412"/>
             </a:avLst>
           </a:prstGeom>
           <a:solidFill>
-            <a:srgbClr val="FFFFFF"/>
+            <a:srgbClr val="EEF2F4"/>
           </a:solidFill>
           <a:ln w="12700">
             <a:solidFill>
-              <a:srgbClr val="1B2630"/>
+              <a:srgbClr val="EEF2F4"/>
             </a:solidFill>
             <a:prstDash val="solid"/>
           </a:ln>
@@ -4322,14 +4448,14 @@
       </p:sp>
       <p:sp>
         <p:nvSpPr>
-          <p:cNvPr id="11" name="Text 8"/>
+          <p:cNvPr id="12" name="Text 9"/>
           <p:cNvSpPr txBox="1"/>
           <p:nvPr/>
         </p:nvSpPr>
         <p:spPr>
           <a:xfrm>
-            <a:off x="7104888" y="1298448"/>
-            <a:ext cx="548640" cy="237744"/>
+            <a:off x="5303520" y="2907792"/>
+            <a:ext cx="3337560" cy="256032"/>
           </a:xfrm>
           <a:prstGeom prst="rect">
             <a:avLst/>
@@ -4338,14 +4464,14 @@
           <a:ln/>
         </p:spPr>
         <p:txBody>
-          <a:bodyPr wrap="square" lIns="0" tIns="0" rIns="0" bIns="0" rtlCol="0" anchor="ctr"/>
-          <a:lstStyle/>
-          <a:p>
-            <a:pPr algn="ctr" indent="0" marL="0">
+          <a:bodyPr wrap="square" lIns="0" tIns="0" rIns="0" bIns="0" rtlCol="0" anchor="t"/>
+          <a:lstStyle/>
+          <a:p>
+            <a:pPr indent="0" marL="0">
               <a:buNone/>
             </a:pPr>
             <a:r>
-              <a:rPr lang="en-US" sz="1100" dirty="0">
+              <a:rPr lang="en-US" sz="1300" b="1" dirty="0">
                 <a:solidFill>
                   <a:schemeClr val="tx1"/>
                 </a:solidFill>
@@ -4353,38 +4479,11 @@
                 <a:ea typeface="Courier New" pitchFamily="34" charset="-122"/>
                 <a:cs typeface="Courier New" pitchFamily="34" charset="-120"/>
               </a:rPr>
-              <a:t>x2</a:t>
-            </a:r>
-            <a:endParaRPr lang="en-US" sz="1100" dirty="0"/>
-          </a:p>
-        </p:txBody>
-      </p:sp>
-      <p:sp>
-        <p:nvSpPr>
-          <p:cNvPr id="12" name="bcast-3"/>
-          <p:cNvSpPr/>
-          <p:nvPr/>
-        </p:nvSpPr>
-        <p:spPr>
-          <a:xfrm>
-            <a:off x="7708392" y="1298448"/>
-            <a:ext cx="548640" cy="237744"/>
-          </a:xfrm>
-          <a:prstGeom prst="roundRect">
-            <a:avLst>
-              <a:gd name="adj" fmla="val 15385"/>
-            </a:avLst>
-          </a:prstGeom>
-          <a:solidFill>
-            <a:srgbClr val="FFFFFF"/>
-          </a:solidFill>
-          <a:ln w="12700">
-            <a:solidFill>
-              <a:srgbClr val="1B2630"/>
-            </a:solidFill>
-            <a:prstDash val="solid"/>
-          </a:ln>
-        </p:spPr>
+              <a:t>accumulator</a:t>
+            </a:r>
+            <a:endParaRPr lang="en-US" sz="1300" dirty="0"/>
+          </a:p>
+        </p:txBody>
       </p:sp>
       <p:sp>
         <p:nvSpPr>
@@ -4394,8 +4493,8 @@
         </p:nvSpPr>
         <p:spPr>
           <a:xfrm>
-            <a:off x="7708392" y="1298448"/>
-            <a:ext cx="548640" cy="237744"/>
+            <a:off x="5303520" y="3182112"/>
+            <a:ext cx="3337560" cy="411480"/>
           </a:xfrm>
           <a:prstGeom prst="rect">
             <a:avLst/>
@@ -4404,22 +4503,19 @@
           <a:ln/>
         </p:spPr>
         <p:txBody>
-          <a:bodyPr wrap="square" lIns="0" tIns="0" rIns="0" bIns="0" rtlCol="0" anchor="ctr"/>
-          <a:lstStyle/>
-          <a:p>
-            <a:pPr algn="ctr" indent="0" marL="0">
+          <a:bodyPr wrap="square" lIns="0" tIns="0" rIns="0" bIns="0" rtlCol="0" anchor="t"/>
+          <a:lstStyle/>
+          <a:p>
+            <a:pPr indent="0" marL="0">
               <a:buNone/>
             </a:pPr>
             <a:r>
               <a:rPr lang="en-US" sz="1100" dirty="0">
                 <a:solidFill>
-                  <a:schemeClr val="tx1"/>
-                </a:solidFill>
-                <a:latin typeface="Courier New" pitchFamily="34" charset="0"/>
-                <a:ea typeface="Courier New" pitchFamily="34" charset="-122"/>
-                <a:cs typeface="Courier New" pitchFamily="34" charset="-120"/>
+                  <a:schemeClr val="tx2"/>
+                </a:solidFill>
               </a:rPr>
-              <a:t>x3</a:t>
+              <a:t>one YMM register = 8 outputs (8 channels of one pixel); one dependency chain</a:t>
             </a:r>
             <a:endParaRPr lang="en-US" sz="1100" dirty="0"/>
           </a:p>
@@ -4427,150 +4523,18 @@
       </p:sp>
       <p:sp>
         <p:nvSpPr>
-          <p:cNvPr id="14" name="bcast-4"/>
+          <p:cNvPr id="14" name="term-3"/>
           <p:cNvSpPr/>
           <p:nvPr/>
         </p:nvSpPr>
         <p:spPr>
           <a:xfrm>
-            <a:off x="8311896" y="1298448"/>
-            <a:ext cx="548640" cy="237744"/>
+            <a:off x="5166360" y="3703320"/>
+            <a:ext cx="3566160" cy="777240"/>
           </a:xfrm>
           <a:prstGeom prst="roundRect">
             <a:avLst>
-              <a:gd name="adj" fmla="val 15385"/>
-            </a:avLst>
-          </a:prstGeom>
-          <a:solidFill>
-            <a:srgbClr val="FFFFFF"/>
-          </a:solidFill>
-          <a:ln w="12700">
-            <a:solidFill>
-              <a:srgbClr val="1B2630"/>
-            </a:solidFill>
-            <a:prstDash val="solid"/>
-          </a:ln>
-        </p:spPr>
-      </p:sp>
-      <p:sp>
-        <p:nvSpPr>
-          <p:cNvPr id="15" name="Text 12"/>
-          <p:cNvSpPr txBox="1"/>
-          <p:nvPr/>
-        </p:nvSpPr>
-        <p:spPr>
-          <a:xfrm>
-            <a:off x="8311896" y="1298448"/>
-            <a:ext cx="548640" cy="237744"/>
-          </a:xfrm>
-          <a:prstGeom prst="rect">
-            <a:avLst/>
-          </a:prstGeom>
-          <a:noFill/>
-          <a:ln/>
-        </p:spPr>
-        <p:txBody>
-          <a:bodyPr wrap="square" lIns="0" tIns="0" rIns="0" bIns="0" rtlCol="0" anchor="ctr"/>
-          <a:lstStyle/>
-          <a:p>
-            <a:pPr algn="ctr" indent="0" marL="0">
-              <a:buNone/>
-            </a:pPr>
-            <a:r>
-              <a:rPr lang="en-US" sz="1100" dirty="0">
-                <a:solidFill>
-                  <a:schemeClr val="tx1"/>
-                </a:solidFill>
-                <a:latin typeface="Courier New" pitchFamily="34" charset="0"/>
-                <a:ea typeface="Courier New" pitchFamily="34" charset="-122"/>
-                <a:cs typeface="Courier New" pitchFamily="34" charset="-120"/>
-              </a:rPr>
-              <a:t>x4</a:t>
-            </a:r>
-            <a:endParaRPr lang="en-US" sz="1100" dirty="0"/>
-          </a:p>
-        </p:txBody>
-      </p:sp>
-      <p:sp>
-        <p:nvSpPr>
-          <p:cNvPr id="16" name="weight-0"/>
-          <p:cNvSpPr/>
-          <p:nvPr/>
-        </p:nvSpPr>
-        <p:spPr>
-          <a:xfrm>
-            <a:off x="5330952" y="1600200"/>
-            <a:ext cx="457200" cy="566928"/>
-          </a:xfrm>
-          <a:prstGeom prst="roundRect">
-            <a:avLst>
-              <a:gd name="adj" fmla="val 8000"/>
-            </a:avLst>
-          </a:prstGeom>
-          <a:solidFill>
-            <a:srgbClr val="F5E6CF"/>
-          </a:solidFill>
-          <a:ln w="12700">
-            <a:solidFill>
-              <a:srgbClr val="B7731A"/>
-            </a:solidFill>
-            <a:prstDash val="solid"/>
-          </a:ln>
-        </p:spPr>
-      </p:sp>
-      <p:sp>
-        <p:nvSpPr>
-          <p:cNvPr id="17" name="Text 14"/>
-          <p:cNvSpPr txBox="1"/>
-          <p:nvPr/>
-        </p:nvSpPr>
-        <p:spPr>
-          <a:xfrm>
-            <a:off x="5330952" y="1600200"/>
-            <a:ext cx="457200" cy="566928"/>
-          </a:xfrm>
-          <a:prstGeom prst="rect">
-            <a:avLst/>
-          </a:prstGeom>
-          <a:noFill/>
-          <a:ln/>
-        </p:spPr>
-        <p:txBody>
-          <a:bodyPr wrap="square" lIns="0" tIns="0" rIns="0" bIns="0" rtlCol="0" anchor="ctr"/>
-          <a:lstStyle/>
-          <a:p>
-            <a:pPr algn="ctr" indent="0" marL="0">
-              <a:buNone/>
-            </a:pPr>
-            <a:r>
-              <a:rPr lang="en-US" sz="1200" dirty="0">
-                <a:solidFill>
-                  <a:schemeClr val="tx1"/>
-                </a:solidFill>
-                <a:latin typeface="Courier New" pitchFamily="34" charset="0"/>
-                <a:ea typeface="Courier New" pitchFamily="34" charset="-122"/>
-                <a:cs typeface="Courier New" pitchFamily="34" charset="-120"/>
-              </a:rPr>
-              <a:t>w0</a:t>
-            </a:r>
-            <a:endParaRPr lang="en-US" sz="1200" dirty="0"/>
-          </a:p>
-        </p:txBody>
-      </p:sp>
-      <p:sp>
-        <p:nvSpPr>
-          <p:cNvPr id="18" name="acc-0-0"/>
-          <p:cNvSpPr/>
-          <p:nvPr/>
-        </p:nvSpPr>
-        <p:spPr>
-          <a:xfrm>
-            <a:off x="5897880" y="1600200"/>
-            <a:ext cx="548640" cy="566928"/>
-          </a:xfrm>
-          <a:prstGeom prst="roundRect">
-            <a:avLst>
-              <a:gd name="adj" fmla="val 8333"/>
+              <a:gd name="adj" fmla="val 9412"/>
             </a:avLst>
           </a:prstGeom>
           <a:solidFill>
@@ -4578,7 +4542,7 @@
           </a:solidFill>
           <a:ln w="12700">
             <a:solidFill>
-              <a:srgbClr val="0C6A87"/>
+              <a:srgbClr val="D7EAF0"/>
             </a:solidFill>
             <a:prstDash val="solid"/>
           </a:ln>
@@ -4586,14 +4550,14 @@
       </p:sp>
       <p:sp>
         <p:nvSpPr>
-          <p:cNvPr id="19" name="Text 16"/>
+          <p:cNvPr id="15" name="Text 12"/>
           <p:cNvSpPr txBox="1"/>
           <p:nvPr/>
         </p:nvSpPr>
         <p:spPr>
           <a:xfrm>
-            <a:off x="5897880" y="1600200"/>
-            <a:ext cx="548640" cy="566928"/>
+            <a:off x="5303520" y="3776472"/>
+            <a:ext cx="3337560" cy="256032"/>
           </a:xfrm>
           <a:prstGeom prst="rect">
             <a:avLst/>
@@ -4602,867 +4566,37 @@
           <a:ln/>
         </p:spPr>
         <p:txBody>
-          <a:bodyPr wrap="square" lIns="0" tIns="0" rIns="0" bIns="0" rtlCol="0" anchor="ctr"/>
-          <a:lstStyle/>
-          <a:p>
-            <a:pPr algn="ctr" indent="0" marL="0">
+          <a:bodyPr wrap="square" lIns="0" tIns="0" rIns="0" bIns="0" rtlCol="0" anchor="t"/>
+          <a:lstStyle/>
+          <a:p>
+            <a:pPr indent="0" marL="0">
               <a:buNone/>
             </a:pPr>
             <a:r>
-              <a:rPr lang="en-US" sz="1000" dirty="0">
-                <a:solidFill>
-                  <a:schemeClr val="tx1"/>
+              <a:rPr lang="en-US" sz="1300" b="1" dirty="0">
+                <a:solidFill>
+                  <a:schemeClr val="accent1"/>
                 </a:solidFill>
                 <a:latin typeface="Courier New" pitchFamily="34" charset="0"/>
                 <a:ea typeface="Courier New" pitchFamily="34" charset="-122"/>
                 <a:cs typeface="Courier New" pitchFamily="34" charset="-120"/>
               </a:rPr>
-              <a:t>acc</a:t>
-            </a:r>
-            <a:endParaRPr lang="en-US" sz="1000" dirty="0"/>
-          </a:p>
-          <a:p>
-            <a:pPr algn="ctr" indent="0" marL="0">
-              <a:buNone/>
-            </a:pPr>
-            <a:r>
-              <a:rPr lang="en-US" sz="1000" dirty="0">
-                <a:solidFill>
-                  <a:schemeClr val="tx1"/>
-                </a:solidFill>
-                <a:latin typeface="Courier New" pitchFamily="34" charset="0"/>
-                <a:ea typeface="Courier New" pitchFamily="34" charset="-122"/>
-                <a:cs typeface="Courier New" pitchFamily="34" charset="-120"/>
-              </a:rPr>
-              <a:t>0,0</a:t>
-            </a:r>
-            <a:endParaRPr lang="en-US" sz="1000" dirty="0"/>
-          </a:p>
-        </p:txBody>
-      </p:sp>
-      <p:sp>
-        <p:nvSpPr>
-          <p:cNvPr id="20" name="acc-0-1"/>
-          <p:cNvSpPr/>
-          <p:nvPr/>
-        </p:nvSpPr>
-        <p:spPr>
-          <a:xfrm>
-            <a:off x="6501384" y="1600200"/>
-            <a:ext cx="548640" cy="566928"/>
-          </a:xfrm>
-          <a:prstGeom prst="roundRect">
-            <a:avLst>
-              <a:gd name="adj" fmla="val 8333"/>
-            </a:avLst>
-          </a:prstGeom>
-          <a:solidFill>
-            <a:srgbClr val="D7EAF0"/>
-          </a:solidFill>
-          <a:ln w="12700">
-            <a:solidFill>
-              <a:srgbClr val="0C6A87"/>
-            </a:solidFill>
-            <a:prstDash val="solid"/>
-          </a:ln>
-        </p:spPr>
-      </p:sp>
-      <p:sp>
-        <p:nvSpPr>
-          <p:cNvPr id="21" name="Text 18"/>
+              <a:t>tile 2×5 (10)</a:t>
+            </a:r>
+            <a:endParaRPr lang="en-US" sz="1300" dirty="0"/>
+          </a:p>
+        </p:txBody>
+      </p:sp>
+      <p:sp>
+        <p:nvSpPr>
+          <p:cNvPr id="16" name="Text 13"/>
           <p:cNvSpPr txBox="1"/>
           <p:nvPr/>
         </p:nvSpPr>
         <p:spPr>
           <a:xfrm>
-            <a:off x="6501384" y="1600200"/>
-            <a:ext cx="548640" cy="566928"/>
-          </a:xfrm>
-          <a:prstGeom prst="rect">
-            <a:avLst/>
-          </a:prstGeom>
-          <a:noFill/>
-          <a:ln/>
-        </p:spPr>
-        <p:txBody>
-          <a:bodyPr wrap="square" lIns="0" tIns="0" rIns="0" bIns="0" rtlCol="0" anchor="ctr"/>
-          <a:lstStyle/>
-          <a:p>
-            <a:pPr algn="ctr" indent="0" marL="0">
-              <a:buNone/>
-            </a:pPr>
-            <a:r>
-              <a:rPr lang="en-US" sz="1000" dirty="0">
-                <a:solidFill>
-                  <a:schemeClr val="tx1"/>
-                </a:solidFill>
-                <a:latin typeface="Courier New" pitchFamily="34" charset="0"/>
-                <a:ea typeface="Courier New" pitchFamily="34" charset="-122"/>
-                <a:cs typeface="Courier New" pitchFamily="34" charset="-120"/>
-              </a:rPr>
-              <a:t>acc</a:t>
-            </a:r>
-            <a:endParaRPr lang="en-US" sz="1000" dirty="0"/>
-          </a:p>
-          <a:p>
-            <a:pPr algn="ctr" indent="0" marL="0">
-              <a:buNone/>
-            </a:pPr>
-            <a:r>
-              <a:rPr lang="en-US" sz="1000" dirty="0">
-                <a:solidFill>
-                  <a:schemeClr val="tx1"/>
-                </a:solidFill>
-                <a:latin typeface="Courier New" pitchFamily="34" charset="0"/>
-                <a:ea typeface="Courier New" pitchFamily="34" charset="-122"/>
-                <a:cs typeface="Courier New" pitchFamily="34" charset="-120"/>
-              </a:rPr>
-              <a:t>0,1</a:t>
-            </a:r>
-            <a:endParaRPr lang="en-US" sz="1000" dirty="0"/>
-          </a:p>
-        </p:txBody>
-      </p:sp>
-      <p:sp>
-        <p:nvSpPr>
-          <p:cNvPr id="22" name="acc-0-2"/>
-          <p:cNvSpPr/>
-          <p:nvPr/>
-        </p:nvSpPr>
-        <p:spPr>
-          <a:xfrm>
-            <a:off x="7104888" y="1600200"/>
-            <a:ext cx="548640" cy="566928"/>
-          </a:xfrm>
-          <a:prstGeom prst="roundRect">
-            <a:avLst>
-              <a:gd name="adj" fmla="val 8333"/>
-            </a:avLst>
-          </a:prstGeom>
-          <a:solidFill>
-            <a:srgbClr val="D7EAF0"/>
-          </a:solidFill>
-          <a:ln w="12700">
-            <a:solidFill>
-              <a:srgbClr val="0C6A87"/>
-            </a:solidFill>
-            <a:prstDash val="solid"/>
-          </a:ln>
-        </p:spPr>
-      </p:sp>
-      <p:sp>
-        <p:nvSpPr>
-          <p:cNvPr id="23" name="Text 20"/>
-          <p:cNvSpPr txBox="1"/>
-          <p:nvPr/>
-        </p:nvSpPr>
-        <p:spPr>
-          <a:xfrm>
-            <a:off x="7104888" y="1600200"/>
-            <a:ext cx="548640" cy="566928"/>
-          </a:xfrm>
-          <a:prstGeom prst="rect">
-            <a:avLst/>
-          </a:prstGeom>
-          <a:noFill/>
-          <a:ln/>
-        </p:spPr>
-        <p:txBody>
-          <a:bodyPr wrap="square" lIns="0" tIns="0" rIns="0" bIns="0" rtlCol="0" anchor="ctr"/>
-          <a:lstStyle/>
-          <a:p>
-            <a:pPr algn="ctr" indent="0" marL="0">
-              <a:buNone/>
-            </a:pPr>
-            <a:r>
-              <a:rPr lang="en-US" sz="1000" dirty="0">
-                <a:solidFill>
-                  <a:schemeClr val="tx1"/>
-                </a:solidFill>
-                <a:latin typeface="Courier New" pitchFamily="34" charset="0"/>
-                <a:ea typeface="Courier New" pitchFamily="34" charset="-122"/>
-                <a:cs typeface="Courier New" pitchFamily="34" charset="-120"/>
-              </a:rPr>
-              <a:t>acc</a:t>
-            </a:r>
-            <a:endParaRPr lang="en-US" sz="1000" dirty="0"/>
-          </a:p>
-          <a:p>
-            <a:pPr algn="ctr" indent="0" marL="0">
-              <a:buNone/>
-            </a:pPr>
-            <a:r>
-              <a:rPr lang="en-US" sz="1000" dirty="0">
-                <a:solidFill>
-                  <a:schemeClr val="tx1"/>
-                </a:solidFill>
-                <a:latin typeface="Courier New" pitchFamily="34" charset="0"/>
-                <a:ea typeface="Courier New" pitchFamily="34" charset="-122"/>
-                <a:cs typeface="Courier New" pitchFamily="34" charset="-120"/>
-              </a:rPr>
-              <a:t>0,2</a:t>
-            </a:r>
-            <a:endParaRPr lang="en-US" sz="1000" dirty="0"/>
-          </a:p>
-        </p:txBody>
-      </p:sp>
-      <p:sp>
-        <p:nvSpPr>
-          <p:cNvPr id="24" name="acc-0-3"/>
-          <p:cNvSpPr/>
-          <p:nvPr/>
-        </p:nvSpPr>
-        <p:spPr>
-          <a:xfrm>
-            <a:off x="7708392" y="1600200"/>
-            <a:ext cx="548640" cy="566928"/>
-          </a:xfrm>
-          <a:prstGeom prst="roundRect">
-            <a:avLst>
-              <a:gd name="adj" fmla="val 8333"/>
-            </a:avLst>
-          </a:prstGeom>
-          <a:solidFill>
-            <a:srgbClr val="D7EAF0"/>
-          </a:solidFill>
-          <a:ln w="12700">
-            <a:solidFill>
-              <a:srgbClr val="0C6A87"/>
-            </a:solidFill>
-            <a:prstDash val="solid"/>
-          </a:ln>
-        </p:spPr>
-      </p:sp>
-      <p:sp>
-        <p:nvSpPr>
-          <p:cNvPr id="25" name="Text 22"/>
-          <p:cNvSpPr txBox="1"/>
-          <p:nvPr/>
-        </p:nvSpPr>
-        <p:spPr>
-          <a:xfrm>
-            <a:off x="7708392" y="1600200"/>
-            <a:ext cx="548640" cy="566928"/>
-          </a:xfrm>
-          <a:prstGeom prst="rect">
-            <a:avLst/>
-          </a:prstGeom>
-          <a:noFill/>
-          <a:ln/>
-        </p:spPr>
-        <p:txBody>
-          <a:bodyPr wrap="square" lIns="0" tIns="0" rIns="0" bIns="0" rtlCol="0" anchor="ctr"/>
-          <a:lstStyle/>
-          <a:p>
-            <a:pPr algn="ctr" indent="0" marL="0">
-              <a:buNone/>
-            </a:pPr>
-            <a:r>
-              <a:rPr lang="en-US" sz="1000" dirty="0">
-                <a:solidFill>
-                  <a:schemeClr val="tx1"/>
-                </a:solidFill>
-                <a:latin typeface="Courier New" pitchFamily="34" charset="0"/>
-                <a:ea typeface="Courier New" pitchFamily="34" charset="-122"/>
-                <a:cs typeface="Courier New" pitchFamily="34" charset="-120"/>
-              </a:rPr>
-              <a:t>acc</a:t>
-            </a:r>
-            <a:endParaRPr lang="en-US" sz="1000" dirty="0"/>
-          </a:p>
-          <a:p>
-            <a:pPr algn="ctr" indent="0" marL="0">
-              <a:buNone/>
-            </a:pPr>
-            <a:r>
-              <a:rPr lang="en-US" sz="1000" dirty="0">
-                <a:solidFill>
-                  <a:schemeClr val="tx1"/>
-                </a:solidFill>
-                <a:latin typeface="Courier New" pitchFamily="34" charset="0"/>
-                <a:ea typeface="Courier New" pitchFamily="34" charset="-122"/>
-                <a:cs typeface="Courier New" pitchFamily="34" charset="-120"/>
-              </a:rPr>
-              <a:t>0,3</a:t>
-            </a:r>
-            <a:endParaRPr lang="en-US" sz="1000" dirty="0"/>
-          </a:p>
-        </p:txBody>
-      </p:sp>
-      <p:sp>
-        <p:nvSpPr>
-          <p:cNvPr id="26" name="acc-0-4"/>
-          <p:cNvSpPr/>
-          <p:nvPr/>
-        </p:nvSpPr>
-        <p:spPr>
-          <a:xfrm>
-            <a:off x="8311896" y="1600200"/>
-            <a:ext cx="548640" cy="566928"/>
-          </a:xfrm>
-          <a:prstGeom prst="roundRect">
-            <a:avLst>
-              <a:gd name="adj" fmla="val 8333"/>
-            </a:avLst>
-          </a:prstGeom>
-          <a:solidFill>
-            <a:srgbClr val="D7EAF0"/>
-          </a:solidFill>
-          <a:ln w="12700">
-            <a:solidFill>
-              <a:srgbClr val="0C6A87"/>
-            </a:solidFill>
-            <a:prstDash val="solid"/>
-          </a:ln>
-        </p:spPr>
-      </p:sp>
-      <p:sp>
-        <p:nvSpPr>
-          <p:cNvPr id="27" name="Text 24"/>
-          <p:cNvSpPr txBox="1"/>
-          <p:nvPr/>
-        </p:nvSpPr>
-        <p:spPr>
-          <a:xfrm>
-            <a:off x="8311896" y="1600200"/>
-            <a:ext cx="548640" cy="566928"/>
-          </a:xfrm>
-          <a:prstGeom prst="rect">
-            <a:avLst/>
-          </a:prstGeom>
-          <a:noFill/>
-          <a:ln/>
-        </p:spPr>
-        <p:txBody>
-          <a:bodyPr wrap="square" lIns="0" tIns="0" rIns="0" bIns="0" rtlCol="0" anchor="ctr"/>
-          <a:lstStyle/>
-          <a:p>
-            <a:pPr algn="ctr" indent="0" marL="0">
-              <a:buNone/>
-            </a:pPr>
-            <a:r>
-              <a:rPr lang="en-US" sz="1000" dirty="0">
-                <a:solidFill>
-                  <a:schemeClr val="tx1"/>
-                </a:solidFill>
-                <a:latin typeface="Courier New" pitchFamily="34" charset="0"/>
-                <a:ea typeface="Courier New" pitchFamily="34" charset="-122"/>
-                <a:cs typeface="Courier New" pitchFamily="34" charset="-120"/>
-              </a:rPr>
-              <a:t>acc</a:t>
-            </a:r>
-            <a:endParaRPr lang="en-US" sz="1000" dirty="0"/>
-          </a:p>
-          <a:p>
-            <a:pPr algn="ctr" indent="0" marL="0">
-              <a:buNone/>
-            </a:pPr>
-            <a:r>
-              <a:rPr lang="en-US" sz="1000" dirty="0">
-                <a:solidFill>
-                  <a:schemeClr val="tx1"/>
-                </a:solidFill>
-                <a:latin typeface="Courier New" pitchFamily="34" charset="0"/>
-                <a:ea typeface="Courier New" pitchFamily="34" charset="-122"/>
-                <a:cs typeface="Courier New" pitchFamily="34" charset="-120"/>
-              </a:rPr>
-              <a:t>0,4</a:t>
-            </a:r>
-            <a:endParaRPr lang="en-US" sz="1000" dirty="0"/>
-          </a:p>
-        </p:txBody>
-      </p:sp>
-      <p:sp>
-        <p:nvSpPr>
-          <p:cNvPr id="28" name="weight-1"/>
-          <p:cNvSpPr/>
-          <p:nvPr/>
-        </p:nvSpPr>
-        <p:spPr>
-          <a:xfrm>
-            <a:off x="5330952" y="2221992"/>
-            <a:ext cx="457200" cy="566928"/>
-          </a:xfrm>
-          <a:prstGeom prst="roundRect">
-            <a:avLst>
-              <a:gd name="adj" fmla="val 8000"/>
-            </a:avLst>
-          </a:prstGeom>
-          <a:solidFill>
-            <a:srgbClr val="F5E6CF"/>
-          </a:solidFill>
-          <a:ln w="12700">
-            <a:solidFill>
-              <a:srgbClr val="B7731A"/>
-            </a:solidFill>
-            <a:prstDash val="solid"/>
-          </a:ln>
-        </p:spPr>
-      </p:sp>
-      <p:sp>
-        <p:nvSpPr>
-          <p:cNvPr id="29" name="Text 26"/>
-          <p:cNvSpPr txBox="1"/>
-          <p:nvPr/>
-        </p:nvSpPr>
-        <p:spPr>
-          <a:xfrm>
-            <a:off x="5330952" y="2221992"/>
-            <a:ext cx="457200" cy="566928"/>
-          </a:xfrm>
-          <a:prstGeom prst="rect">
-            <a:avLst/>
-          </a:prstGeom>
-          <a:noFill/>
-          <a:ln/>
-        </p:spPr>
-        <p:txBody>
-          <a:bodyPr wrap="square" lIns="0" tIns="0" rIns="0" bIns="0" rtlCol="0" anchor="ctr"/>
-          <a:lstStyle/>
-          <a:p>
-            <a:pPr algn="ctr" indent="0" marL="0">
-              <a:buNone/>
-            </a:pPr>
-            <a:r>
-              <a:rPr lang="en-US" sz="1200" dirty="0">
-                <a:solidFill>
-                  <a:schemeClr val="tx1"/>
-                </a:solidFill>
-                <a:latin typeface="Courier New" pitchFamily="34" charset="0"/>
-                <a:ea typeface="Courier New" pitchFamily="34" charset="-122"/>
-                <a:cs typeface="Courier New" pitchFamily="34" charset="-120"/>
-              </a:rPr>
-              <a:t>w1</a:t>
-            </a:r>
-            <a:endParaRPr lang="en-US" sz="1200" dirty="0"/>
-          </a:p>
-        </p:txBody>
-      </p:sp>
-      <p:sp>
-        <p:nvSpPr>
-          <p:cNvPr id="30" name="acc-1-0"/>
-          <p:cNvSpPr/>
-          <p:nvPr/>
-        </p:nvSpPr>
-        <p:spPr>
-          <a:xfrm>
-            <a:off x="5897880" y="2221992"/>
-            <a:ext cx="548640" cy="566928"/>
-          </a:xfrm>
-          <a:prstGeom prst="roundRect">
-            <a:avLst>
-              <a:gd name="adj" fmla="val 8333"/>
-            </a:avLst>
-          </a:prstGeom>
-          <a:solidFill>
-            <a:srgbClr val="D7EAF0"/>
-          </a:solidFill>
-          <a:ln w="12700">
-            <a:solidFill>
-              <a:srgbClr val="0C6A87"/>
-            </a:solidFill>
-            <a:prstDash val="solid"/>
-          </a:ln>
-        </p:spPr>
-      </p:sp>
-      <p:sp>
-        <p:nvSpPr>
-          <p:cNvPr id="31" name="Text 28"/>
-          <p:cNvSpPr txBox="1"/>
-          <p:nvPr/>
-        </p:nvSpPr>
-        <p:spPr>
-          <a:xfrm>
-            <a:off x="5897880" y="2221992"/>
-            <a:ext cx="548640" cy="566928"/>
-          </a:xfrm>
-          <a:prstGeom prst="rect">
-            <a:avLst/>
-          </a:prstGeom>
-          <a:noFill/>
-          <a:ln/>
-        </p:spPr>
-        <p:txBody>
-          <a:bodyPr wrap="square" lIns="0" tIns="0" rIns="0" bIns="0" rtlCol="0" anchor="ctr"/>
-          <a:lstStyle/>
-          <a:p>
-            <a:pPr algn="ctr" indent="0" marL="0">
-              <a:buNone/>
-            </a:pPr>
-            <a:r>
-              <a:rPr lang="en-US" sz="1000" dirty="0">
-                <a:solidFill>
-                  <a:schemeClr val="tx1"/>
-                </a:solidFill>
-                <a:latin typeface="Courier New" pitchFamily="34" charset="0"/>
-                <a:ea typeface="Courier New" pitchFamily="34" charset="-122"/>
-                <a:cs typeface="Courier New" pitchFamily="34" charset="-120"/>
-              </a:rPr>
-              <a:t>acc</a:t>
-            </a:r>
-            <a:endParaRPr lang="en-US" sz="1000" dirty="0"/>
-          </a:p>
-          <a:p>
-            <a:pPr algn="ctr" indent="0" marL="0">
-              <a:buNone/>
-            </a:pPr>
-            <a:r>
-              <a:rPr lang="en-US" sz="1000" dirty="0">
-                <a:solidFill>
-                  <a:schemeClr val="tx1"/>
-                </a:solidFill>
-                <a:latin typeface="Courier New" pitchFamily="34" charset="0"/>
-                <a:ea typeface="Courier New" pitchFamily="34" charset="-122"/>
-                <a:cs typeface="Courier New" pitchFamily="34" charset="-120"/>
-              </a:rPr>
-              <a:t>1,0</a:t>
-            </a:r>
-            <a:endParaRPr lang="en-US" sz="1000" dirty="0"/>
-          </a:p>
-        </p:txBody>
-      </p:sp>
-      <p:sp>
-        <p:nvSpPr>
-          <p:cNvPr id="32" name="acc-1-1"/>
-          <p:cNvSpPr/>
-          <p:nvPr/>
-        </p:nvSpPr>
-        <p:spPr>
-          <a:xfrm>
-            <a:off x="6501384" y="2221992"/>
-            <a:ext cx="548640" cy="566928"/>
-          </a:xfrm>
-          <a:prstGeom prst="roundRect">
-            <a:avLst>
-              <a:gd name="adj" fmla="val 8333"/>
-            </a:avLst>
-          </a:prstGeom>
-          <a:solidFill>
-            <a:srgbClr val="D7EAF0"/>
-          </a:solidFill>
-          <a:ln w="12700">
-            <a:solidFill>
-              <a:srgbClr val="0C6A87"/>
-            </a:solidFill>
-            <a:prstDash val="solid"/>
-          </a:ln>
-        </p:spPr>
-      </p:sp>
-      <p:sp>
-        <p:nvSpPr>
-          <p:cNvPr id="33" name="Text 30"/>
-          <p:cNvSpPr txBox="1"/>
-          <p:nvPr/>
-        </p:nvSpPr>
-        <p:spPr>
-          <a:xfrm>
-            <a:off x="6501384" y="2221992"/>
-            <a:ext cx="548640" cy="566928"/>
-          </a:xfrm>
-          <a:prstGeom prst="rect">
-            <a:avLst/>
-          </a:prstGeom>
-          <a:noFill/>
-          <a:ln/>
-        </p:spPr>
-        <p:txBody>
-          <a:bodyPr wrap="square" lIns="0" tIns="0" rIns="0" bIns="0" rtlCol="0" anchor="ctr"/>
-          <a:lstStyle/>
-          <a:p>
-            <a:pPr algn="ctr" indent="0" marL="0">
-              <a:buNone/>
-            </a:pPr>
-            <a:r>
-              <a:rPr lang="en-US" sz="1000" dirty="0">
-                <a:solidFill>
-                  <a:schemeClr val="tx1"/>
-                </a:solidFill>
-                <a:latin typeface="Courier New" pitchFamily="34" charset="0"/>
-                <a:ea typeface="Courier New" pitchFamily="34" charset="-122"/>
-                <a:cs typeface="Courier New" pitchFamily="34" charset="-120"/>
-              </a:rPr>
-              <a:t>acc</a:t>
-            </a:r>
-            <a:endParaRPr lang="en-US" sz="1000" dirty="0"/>
-          </a:p>
-          <a:p>
-            <a:pPr algn="ctr" indent="0" marL="0">
-              <a:buNone/>
-            </a:pPr>
-            <a:r>
-              <a:rPr lang="en-US" sz="1000" dirty="0">
-                <a:solidFill>
-                  <a:schemeClr val="tx1"/>
-                </a:solidFill>
-                <a:latin typeface="Courier New" pitchFamily="34" charset="0"/>
-                <a:ea typeface="Courier New" pitchFamily="34" charset="-122"/>
-                <a:cs typeface="Courier New" pitchFamily="34" charset="-120"/>
-              </a:rPr>
-              <a:t>1,1</a:t>
-            </a:r>
-            <a:endParaRPr lang="en-US" sz="1000" dirty="0"/>
-          </a:p>
-        </p:txBody>
-      </p:sp>
-      <p:sp>
-        <p:nvSpPr>
-          <p:cNvPr id="34" name="acc-1-2"/>
-          <p:cNvSpPr/>
-          <p:nvPr/>
-        </p:nvSpPr>
-        <p:spPr>
-          <a:xfrm>
-            <a:off x="7104888" y="2221992"/>
-            <a:ext cx="548640" cy="566928"/>
-          </a:xfrm>
-          <a:prstGeom prst="roundRect">
-            <a:avLst>
-              <a:gd name="adj" fmla="val 8333"/>
-            </a:avLst>
-          </a:prstGeom>
-          <a:solidFill>
-            <a:srgbClr val="D7EAF0"/>
-          </a:solidFill>
-          <a:ln w="12700">
-            <a:solidFill>
-              <a:srgbClr val="0C6A87"/>
-            </a:solidFill>
-            <a:prstDash val="solid"/>
-          </a:ln>
-        </p:spPr>
-      </p:sp>
-      <p:sp>
-        <p:nvSpPr>
-          <p:cNvPr id="35" name="Text 32"/>
-          <p:cNvSpPr txBox="1"/>
-          <p:nvPr/>
-        </p:nvSpPr>
-        <p:spPr>
-          <a:xfrm>
-            <a:off x="7104888" y="2221992"/>
-            <a:ext cx="548640" cy="566928"/>
-          </a:xfrm>
-          <a:prstGeom prst="rect">
-            <a:avLst/>
-          </a:prstGeom>
-          <a:noFill/>
-          <a:ln/>
-        </p:spPr>
-        <p:txBody>
-          <a:bodyPr wrap="square" lIns="0" tIns="0" rIns="0" bIns="0" rtlCol="0" anchor="ctr"/>
-          <a:lstStyle/>
-          <a:p>
-            <a:pPr algn="ctr" indent="0" marL="0">
-              <a:buNone/>
-            </a:pPr>
-            <a:r>
-              <a:rPr lang="en-US" sz="1000" dirty="0">
-                <a:solidFill>
-                  <a:schemeClr val="tx1"/>
-                </a:solidFill>
-                <a:latin typeface="Courier New" pitchFamily="34" charset="0"/>
-                <a:ea typeface="Courier New" pitchFamily="34" charset="-122"/>
-                <a:cs typeface="Courier New" pitchFamily="34" charset="-120"/>
-              </a:rPr>
-              <a:t>acc</a:t>
-            </a:r>
-            <a:endParaRPr lang="en-US" sz="1000" dirty="0"/>
-          </a:p>
-          <a:p>
-            <a:pPr algn="ctr" indent="0" marL="0">
-              <a:buNone/>
-            </a:pPr>
-            <a:r>
-              <a:rPr lang="en-US" sz="1000" dirty="0">
-                <a:solidFill>
-                  <a:schemeClr val="tx1"/>
-                </a:solidFill>
-                <a:latin typeface="Courier New" pitchFamily="34" charset="0"/>
-                <a:ea typeface="Courier New" pitchFamily="34" charset="-122"/>
-                <a:cs typeface="Courier New" pitchFamily="34" charset="-120"/>
-              </a:rPr>
-              <a:t>1,2</a:t>
-            </a:r>
-            <a:endParaRPr lang="en-US" sz="1000" dirty="0"/>
-          </a:p>
-        </p:txBody>
-      </p:sp>
-      <p:sp>
-        <p:nvSpPr>
-          <p:cNvPr id="36" name="acc-1-3"/>
-          <p:cNvSpPr/>
-          <p:nvPr/>
-        </p:nvSpPr>
-        <p:spPr>
-          <a:xfrm>
-            <a:off x="7708392" y="2221992"/>
-            <a:ext cx="548640" cy="566928"/>
-          </a:xfrm>
-          <a:prstGeom prst="roundRect">
-            <a:avLst>
-              <a:gd name="adj" fmla="val 8333"/>
-            </a:avLst>
-          </a:prstGeom>
-          <a:solidFill>
-            <a:srgbClr val="D7EAF0"/>
-          </a:solidFill>
-          <a:ln w="12700">
-            <a:solidFill>
-              <a:srgbClr val="0C6A87"/>
-            </a:solidFill>
-            <a:prstDash val="solid"/>
-          </a:ln>
-        </p:spPr>
-      </p:sp>
-      <p:sp>
-        <p:nvSpPr>
-          <p:cNvPr id="37" name="Text 34"/>
-          <p:cNvSpPr txBox="1"/>
-          <p:nvPr/>
-        </p:nvSpPr>
-        <p:spPr>
-          <a:xfrm>
-            <a:off x="7708392" y="2221992"/>
-            <a:ext cx="548640" cy="566928"/>
-          </a:xfrm>
-          <a:prstGeom prst="rect">
-            <a:avLst/>
-          </a:prstGeom>
-          <a:noFill/>
-          <a:ln/>
-        </p:spPr>
-        <p:txBody>
-          <a:bodyPr wrap="square" lIns="0" tIns="0" rIns="0" bIns="0" rtlCol="0" anchor="ctr"/>
-          <a:lstStyle/>
-          <a:p>
-            <a:pPr algn="ctr" indent="0" marL="0">
-              <a:buNone/>
-            </a:pPr>
-            <a:r>
-              <a:rPr lang="en-US" sz="1000" dirty="0">
-                <a:solidFill>
-                  <a:schemeClr val="tx1"/>
-                </a:solidFill>
-                <a:latin typeface="Courier New" pitchFamily="34" charset="0"/>
-                <a:ea typeface="Courier New" pitchFamily="34" charset="-122"/>
-                <a:cs typeface="Courier New" pitchFamily="34" charset="-120"/>
-              </a:rPr>
-              <a:t>acc</a:t>
-            </a:r>
-            <a:endParaRPr lang="en-US" sz="1000" dirty="0"/>
-          </a:p>
-          <a:p>
-            <a:pPr algn="ctr" indent="0" marL="0">
-              <a:buNone/>
-            </a:pPr>
-            <a:r>
-              <a:rPr lang="en-US" sz="1000" dirty="0">
-                <a:solidFill>
-                  <a:schemeClr val="tx1"/>
-                </a:solidFill>
-                <a:latin typeface="Courier New" pitchFamily="34" charset="0"/>
-                <a:ea typeface="Courier New" pitchFamily="34" charset="-122"/>
-                <a:cs typeface="Courier New" pitchFamily="34" charset="-120"/>
-              </a:rPr>
-              <a:t>1,3</a:t>
-            </a:r>
-            <a:endParaRPr lang="en-US" sz="1000" dirty="0"/>
-          </a:p>
-        </p:txBody>
-      </p:sp>
-      <p:sp>
-        <p:nvSpPr>
-          <p:cNvPr id="38" name="acc-1-4"/>
-          <p:cNvSpPr/>
-          <p:nvPr/>
-        </p:nvSpPr>
-        <p:spPr>
-          <a:xfrm>
-            <a:off x="8311896" y="2221992"/>
-            <a:ext cx="548640" cy="566928"/>
-          </a:xfrm>
-          <a:prstGeom prst="roundRect">
-            <a:avLst>
-              <a:gd name="adj" fmla="val 8333"/>
-            </a:avLst>
-          </a:prstGeom>
-          <a:solidFill>
-            <a:srgbClr val="D7EAF0"/>
-          </a:solidFill>
-          <a:ln w="12700">
-            <a:solidFill>
-              <a:srgbClr val="0C6A87"/>
-            </a:solidFill>
-            <a:prstDash val="solid"/>
-          </a:ln>
-        </p:spPr>
-      </p:sp>
-      <p:sp>
-        <p:nvSpPr>
-          <p:cNvPr id="39" name="Text 36"/>
-          <p:cNvSpPr txBox="1"/>
-          <p:nvPr/>
-        </p:nvSpPr>
-        <p:spPr>
-          <a:xfrm>
-            <a:off x="8311896" y="2221992"/>
-            <a:ext cx="548640" cy="566928"/>
-          </a:xfrm>
-          <a:prstGeom prst="rect">
-            <a:avLst/>
-          </a:prstGeom>
-          <a:noFill/>
-          <a:ln/>
-        </p:spPr>
-        <p:txBody>
-          <a:bodyPr wrap="square" lIns="0" tIns="0" rIns="0" bIns="0" rtlCol="0" anchor="ctr"/>
-          <a:lstStyle/>
-          <a:p>
-            <a:pPr algn="ctr" indent="0" marL="0">
-              <a:buNone/>
-            </a:pPr>
-            <a:r>
-              <a:rPr lang="en-US" sz="1000" dirty="0">
-                <a:solidFill>
-                  <a:schemeClr val="tx1"/>
-                </a:solidFill>
-                <a:latin typeface="Courier New" pitchFamily="34" charset="0"/>
-                <a:ea typeface="Courier New" pitchFamily="34" charset="-122"/>
-                <a:cs typeface="Courier New" pitchFamily="34" charset="-120"/>
-              </a:rPr>
-              <a:t>acc</a:t>
-            </a:r>
-            <a:endParaRPr lang="en-US" sz="1000" dirty="0"/>
-          </a:p>
-          <a:p>
-            <a:pPr algn="ctr" indent="0" marL="0">
-              <a:buNone/>
-            </a:pPr>
-            <a:r>
-              <a:rPr lang="en-US" sz="1000" dirty="0">
-                <a:solidFill>
-                  <a:schemeClr val="tx1"/>
-                </a:solidFill>
-                <a:latin typeface="Courier New" pitchFamily="34" charset="0"/>
-                <a:ea typeface="Courier New" pitchFamily="34" charset="-122"/>
-                <a:cs typeface="Courier New" pitchFamily="34" charset="-120"/>
-              </a:rPr>
-              <a:t>1,4</a:t>
-            </a:r>
-            <a:endParaRPr lang="en-US" sz="1000" dirty="0"/>
-          </a:p>
-        </p:txBody>
-      </p:sp>
-      <p:sp>
-        <p:nvSpPr>
-          <p:cNvPr id="40" name="Text 37"/>
-          <p:cNvSpPr txBox="1"/>
-          <p:nvPr/>
-        </p:nvSpPr>
-        <p:spPr>
-          <a:xfrm>
-            <a:off x="5166360" y="3017520"/>
-            <a:ext cx="3520440" cy="868680"/>
+            <a:off x="5303520" y="4050792"/>
+            <a:ext cx="3337560" cy="411480"/>
           </a:xfrm>
           <a:prstGeom prst="rect">
             <a:avLst/>
@@ -5478,50 +4612,14 @@
               <a:buNone/>
             </a:pPr>
             <a:r>
-              <a:rPr lang="en-US" sz="1300" dirty="0">
-                <a:solidFill>
-                  <a:schemeClr val="tx1"/>
+              <a:rPr lang="en-US" sz="1100" dirty="0">
+                <a:solidFill>
+                  <a:schemeClr val="tx2"/>
                 </a:solidFill>
               </a:rPr>
-              <a:t>7 loads feed 10 FMAs = 80 multiply-adds. Each weight is reused 5×, each broadcast 2×; accumulators stay in registers for all C × 9 steps, then one store.</a:t>
-            </a:r>
-            <a:endParaRPr lang="en-US" sz="1300" dirty="0"/>
-          </a:p>
-        </p:txBody>
-      </p:sp>
-      <p:sp>
-        <p:nvSpPr>
-          <p:cNvPr id="41" name="Text 38"/>
-          <p:cNvSpPr txBox="1"/>
-          <p:nvPr/>
-        </p:nvSpPr>
-        <p:spPr>
-          <a:xfrm>
-            <a:off x="5166360" y="3977640"/>
-            <a:ext cx="3520440" cy="457200"/>
-          </a:xfrm>
-          <a:prstGeom prst="rect">
-            <a:avLst/>
-          </a:prstGeom>
-          <a:noFill/>
-          <a:ln/>
-        </p:spPr>
-        <p:txBody>
-          <a:bodyPr wrap="square" lIns="0" tIns="0" rIns="0" bIns="0" rtlCol="0" anchor="t"/>
-          <a:lstStyle/>
-          <a:p>
-            <a:pPr indent="0" marL="0">
-              <a:buNone/>
-            </a:pPr>
-            <a:r>
-              <a:rPr lang="en-US" sz="1300" i="1" dirty="0">
-                <a:solidFill>
-                  <a:schemeClr val="accent1"/>
-                </a:solidFill>
-              </a:rPr>
-              <a:t>m = pixels, n = output channels, k = input channels × 3 × 3</a:t>
-            </a:r>
-            <a:endParaRPr lang="en-US" sz="1300" dirty="0"/>
+              <a:t>outputs per call: 2 blocks of 8 channels × 5 pixels = 80 outputs in 10 accumulators</a:t>
+            </a:r>
+            <a:endParaRPr lang="en-US" sz="1100" dirty="0"/>
           </a:p>
         </p:txBody>
       </p:sp>
@@ -5627,83 +4725,46 @@
                   <a:schemeClr val="tx1"/>
                 </a:solidFill>
               </a:rPr>
-              <a:t>Four steps: ops → accumulators → tile → benchmark</a:t>
+              <a:t>One kernel call = 80 outputs</a:t>
             </a:r>
             <a:endParaRPr lang="en-US" sz="2600" dirty="0"/>
           </a:p>
         </p:txBody>
       </p:sp>
-      <p:sp>
-        <p:nvSpPr>
-          <p:cNvPr id="3" name="step-1"/>
-          <p:cNvSpPr/>
+      <p:pic>
+        <p:nvPicPr>
+          <p:cNvPr id="3" name="Image 0" descr="Input map with a 3 by 7 window across all C channels, 16 filters of 3 by 3 by C, and the output tile of 1 row, 5 pixels and 16 channels">    </p:cNvPr>
+          <p:cNvPicPr>
+            <a:picLocks noChangeAspect="1"/>
+          </p:cNvPicPr>
           <p:nvPr/>
-        </p:nvSpPr>
-        <p:spPr>
-          <a:xfrm>
-            <a:off x="457200" y="1115568"/>
-            <a:ext cx="384048" cy="384048"/>
-          </a:xfrm>
-          <a:prstGeom prst="ellipse">
-            <a:avLst/>
-          </a:prstGeom>
-          <a:solidFill>
-            <a:srgbClr val="0C6A87"/>
-          </a:solidFill>
-          <a:ln w="12700">
-            <a:solidFill>
-              <a:srgbClr val="0C6A87"/>
-            </a:solidFill>
-            <a:prstDash val="solid"/>
-          </a:ln>
-        </p:spPr>
-      </p:sp>
-      <p:sp>
-        <p:nvSpPr>
-          <p:cNvPr id="4" name="Text 2"/>
+        </p:nvPicPr>
+        <p:blipFill>
+          <a:blip r:embed="rId1"/>
+          <a:stretch>
+            <a:fillRect/>
+          </a:stretch>
+        </p:blipFill>
+        <p:spPr>
+          <a:xfrm>
+            <a:off x="457200" y="1097280"/>
+            <a:ext cx="8229600" cy="2395728"/>
+          </a:xfrm>
+          <a:prstGeom prst="rect">
+            <a:avLst/>
+          </a:prstGeom>
+        </p:spPr>
+      </p:pic>
+      <p:sp>
+        <p:nvSpPr>
+          <p:cNvPr id="4" name="Text 1"/>
           <p:cNvSpPr txBox="1"/>
           <p:nvPr/>
         </p:nvSpPr>
         <p:spPr>
           <a:xfrm>
-            <a:off x="457200" y="1115568"/>
-            <a:ext cx="384048" cy="384048"/>
-          </a:xfrm>
-          <a:prstGeom prst="rect">
-            <a:avLst/>
-          </a:prstGeom>
-          <a:noFill/>
-          <a:ln/>
-        </p:spPr>
-        <p:txBody>
-          <a:bodyPr wrap="square" lIns="0" tIns="0" rIns="0" bIns="0" rtlCol="0" anchor="ctr"/>
-          <a:lstStyle/>
-          <a:p>
-            <a:pPr algn="ctr" indent="0" marL="0">
-              <a:buNone/>
-            </a:pPr>
-            <a:r>
-              <a:rPr lang="en-US" sz="1600" b="1" dirty="0">
-                <a:solidFill>
-                  <a:schemeClr val="bg1"/>
-                </a:solidFill>
-              </a:rPr>
-              <a:t>1</a:t>
-            </a:r>
-            <a:endParaRPr lang="en-US" sz="1600" dirty="0"/>
-          </a:p>
-        </p:txBody>
-      </p:sp>
-      <p:sp>
-        <p:nvSpPr>
-          <p:cNvPr id="5" name="Text 3"/>
-          <p:cNvSpPr txBox="1"/>
-          <p:nvPr/>
-        </p:nvSpPr>
-        <p:spPr>
-          <a:xfrm>
-            <a:off x="1005840" y="1097280"/>
-            <a:ext cx="3291840" cy="274320"/>
+            <a:off x="457200" y="3794760"/>
+            <a:ext cx="8229600" cy="731520"/>
           </a:xfrm>
           <a:prstGeom prst="rect">
             <a:avLst/>
@@ -5719,468 +4780,17 @@
               <a:buNone/>
             </a:pPr>
             <a:r>
-              <a:rPr lang="en-US" sz="1500" b="1" dirty="0">
+              <a:rPr lang="en-US" sz="1500" dirty="0">
                 <a:solidFill>
                   <a:schemeClr val="tx1"/>
                 </a:solidFill>
               </a:rPr>
-              <a:t>Independent ops</a:t>
+              <a:t>Per step (one input channel at one of the 9 taps): load 2 weight vectors, broadcast 5 inputs, 10 FMAs. Repeat k = C × 9 times, then bias, SiLU and one store per register.</a:t>
             </a:r>
             <a:endParaRPr lang="en-US" sz="1500" dirty="0"/>
           </a:p>
         </p:txBody>
       </p:sp>
-      <p:sp>
-        <p:nvSpPr>
-          <p:cNvPr id="6" name="Text 4"/>
-          <p:cNvSpPr txBox="1"/>
-          <p:nvPr/>
-        </p:nvSpPr>
-        <p:spPr>
-          <a:xfrm>
-            <a:off x="1005840" y="1389888"/>
-            <a:ext cx="3291840" cy="566928"/>
-          </a:xfrm>
-          <a:prstGeom prst="rect">
-            <a:avLst/>
-          </a:prstGeom>
-          <a:noFill/>
-          <a:ln/>
-        </p:spPr>
-        <p:txBody>
-          <a:bodyPr wrap="square" lIns="0" tIns="0" rIns="0" bIns="0" rtlCol="0" anchor="t"/>
-          <a:lstStyle/>
-          <a:p>
-            <a:pPr indent="0" marL="0">
-              <a:buNone/>
-            </a:pPr>
-            <a:r>
-              <a:rPr lang="en-US" sz="1200" dirty="0">
-                <a:solidFill>
-                  <a:schemeClr val="tx2"/>
-                </a:solidFill>
-              </a:rPr>
-              <a:t>Every output is its own dot product of length C × 9: 102,400 in a 40×40, 64-channel layer.</a:t>
-            </a:r>
-            <a:endParaRPr lang="en-US" sz="1200" dirty="0"/>
-          </a:p>
-        </p:txBody>
-      </p:sp>
-      <p:sp>
-        <p:nvSpPr>
-          <p:cNvPr id="7" name="step-2"/>
-          <p:cNvSpPr/>
-          <p:nvPr/>
-        </p:nvSpPr>
-        <p:spPr>
-          <a:xfrm>
-            <a:off x="457200" y="2011680"/>
-            <a:ext cx="384048" cy="384048"/>
-          </a:xfrm>
-          <a:prstGeom prst="ellipse">
-            <a:avLst/>
-          </a:prstGeom>
-          <a:solidFill>
-            <a:srgbClr val="0C6A87"/>
-          </a:solidFill>
-          <a:ln w="12700">
-            <a:solidFill>
-              <a:srgbClr val="0C6A87"/>
-            </a:solidFill>
-            <a:prstDash val="solid"/>
-          </a:ln>
-        </p:spPr>
-      </p:sp>
-      <p:sp>
-        <p:nvSpPr>
-          <p:cNvPr id="8" name="Text 6"/>
-          <p:cNvSpPr txBox="1"/>
-          <p:nvPr/>
-        </p:nvSpPr>
-        <p:spPr>
-          <a:xfrm>
-            <a:off x="457200" y="2011680"/>
-            <a:ext cx="384048" cy="384048"/>
-          </a:xfrm>
-          <a:prstGeom prst="rect">
-            <a:avLst/>
-          </a:prstGeom>
-          <a:noFill/>
-          <a:ln/>
-        </p:spPr>
-        <p:txBody>
-          <a:bodyPr wrap="square" lIns="0" tIns="0" rIns="0" bIns="0" rtlCol="0" anchor="ctr"/>
-          <a:lstStyle/>
-          <a:p>
-            <a:pPr algn="ctr" indent="0" marL="0">
-              <a:buNone/>
-            </a:pPr>
-            <a:r>
-              <a:rPr lang="en-US" sz="1600" b="1" dirty="0">
-                <a:solidFill>
-                  <a:schemeClr val="bg1"/>
-                </a:solidFill>
-              </a:rPr>
-              <a:t>2</a:t>
-            </a:r>
-            <a:endParaRPr lang="en-US" sz="1600" dirty="0"/>
-          </a:p>
-        </p:txBody>
-      </p:sp>
-      <p:sp>
-        <p:nvSpPr>
-          <p:cNvPr id="9" name="Text 7"/>
-          <p:cNvSpPr txBox="1"/>
-          <p:nvPr/>
-        </p:nvSpPr>
-        <p:spPr>
-          <a:xfrm>
-            <a:off x="1005840" y="1993392"/>
-            <a:ext cx="3291840" cy="274320"/>
-          </a:xfrm>
-          <a:prstGeom prst="rect">
-            <a:avLst/>
-          </a:prstGeom>
-          <a:noFill/>
-          <a:ln/>
-        </p:spPr>
-        <p:txBody>
-          <a:bodyPr wrap="square" lIns="0" tIns="0" rIns="0" bIns="0" rtlCol="0" anchor="t"/>
-          <a:lstStyle/>
-          <a:p>
-            <a:pPr indent="0" marL="0">
-              <a:buNone/>
-            </a:pPr>
-            <a:r>
-              <a:rPr lang="en-US" sz="1500" b="1" dirty="0">
-                <a:solidFill>
-                  <a:schemeClr val="tx1"/>
-                </a:solidFill>
-              </a:rPr>
-              <a:t>Outputs in flight</a:t>
-            </a:r>
-            <a:endParaRPr lang="en-US" sz="1500" dirty="0"/>
-          </a:p>
-        </p:txBody>
-      </p:sp>
-      <p:sp>
-        <p:nvSpPr>
-          <p:cNvPr id="10" name="Text 8"/>
-          <p:cNvSpPr txBox="1"/>
-          <p:nvPr/>
-        </p:nvSpPr>
-        <p:spPr>
-          <a:xfrm>
-            <a:off x="1005840" y="2286000"/>
-            <a:ext cx="3291840" cy="566928"/>
-          </a:xfrm>
-          <a:prstGeom prst="rect">
-            <a:avLst/>
-          </a:prstGeom>
-          <a:noFill/>
-          <a:ln/>
-        </p:spPr>
-        <p:txBody>
-          <a:bodyPr wrap="square" lIns="0" tIns="0" rIns="0" bIns="0" rtlCol="0" anchor="t"/>
-          <a:lstStyle/>
-          <a:p>
-            <a:pPr indent="0" marL="0">
-              <a:buNone/>
-            </a:pPr>
-            <a:r>
-              <a:rPr lang="en-US" sz="1200" dirty="0">
-                <a:solidFill>
-                  <a:schemeClr val="tx2"/>
-                </a:solidFill>
-              </a:rPr>
-              <a:t>Latency 5 × 2 FMA/cycle = 10 accumulators; 1 accumulator runs at exactly 10% of peak.</a:t>
-            </a:r>
-            <a:endParaRPr lang="en-US" sz="1200" dirty="0"/>
-          </a:p>
-        </p:txBody>
-      </p:sp>
-      <p:sp>
-        <p:nvSpPr>
-          <p:cNvPr id="11" name="step-3"/>
-          <p:cNvSpPr/>
-          <p:nvPr/>
-        </p:nvSpPr>
-        <p:spPr>
-          <a:xfrm>
-            <a:off x="457200" y="2907792"/>
-            <a:ext cx="384048" cy="384048"/>
-          </a:xfrm>
-          <a:prstGeom prst="ellipse">
-            <a:avLst/>
-          </a:prstGeom>
-          <a:solidFill>
-            <a:srgbClr val="0C6A87"/>
-          </a:solidFill>
-          <a:ln w="12700">
-            <a:solidFill>
-              <a:srgbClr val="0C6A87"/>
-            </a:solidFill>
-            <a:prstDash val="solid"/>
-          </a:ln>
-        </p:spPr>
-      </p:sp>
-      <p:sp>
-        <p:nvSpPr>
-          <p:cNvPr id="12" name="Text 10"/>
-          <p:cNvSpPr txBox="1"/>
-          <p:nvPr/>
-        </p:nvSpPr>
-        <p:spPr>
-          <a:xfrm>
-            <a:off x="457200" y="2907792"/>
-            <a:ext cx="384048" cy="384048"/>
-          </a:xfrm>
-          <a:prstGeom prst="rect">
-            <a:avLst/>
-          </a:prstGeom>
-          <a:noFill/>
-          <a:ln/>
-        </p:spPr>
-        <p:txBody>
-          <a:bodyPr wrap="square" lIns="0" tIns="0" rIns="0" bIns="0" rtlCol="0" anchor="ctr"/>
-          <a:lstStyle/>
-          <a:p>
-            <a:pPr algn="ctr" indent="0" marL="0">
-              <a:buNone/>
-            </a:pPr>
-            <a:r>
-              <a:rPr lang="en-US" sz="1600" b="1" dirty="0">
-                <a:solidFill>
-                  <a:schemeClr val="bg1"/>
-                </a:solidFill>
-              </a:rPr>
-              <a:t>3</a:t>
-            </a:r>
-            <a:endParaRPr lang="en-US" sz="1600" dirty="0"/>
-          </a:p>
-        </p:txBody>
-      </p:sp>
-      <p:sp>
-        <p:nvSpPr>
-          <p:cNvPr id="13" name="Text 11"/>
-          <p:cNvSpPr txBox="1"/>
-          <p:nvPr/>
-        </p:nvSpPr>
-        <p:spPr>
-          <a:xfrm>
-            <a:off x="1005840" y="2889504"/>
-            <a:ext cx="3291840" cy="274320"/>
-          </a:xfrm>
-          <a:prstGeom prst="rect">
-            <a:avLst/>
-          </a:prstGeom>
-          <a:noFill/>
-          <a:ln/>
-        </p:spPr>
-        <p:txBody>
-          <a:bodyPr wrap="square" lIns="0" tIns="0" rIns="0" bIns="0" rtlCol="0" anchor="t"/>
-          <a:lstStyle/>
-          <a:p>
-            <a:pPr indent="0" marL="0">
-              <a:buNone/>
-            </a:pPr>
-            <a:r>
-              <a:rPr lang="en-US" sz="1500" b="1" dirty="0">
-                <a:solidFill>
-                  <a:schemeClr val="tx1"/>
-                </a:solidFill>
-              </a:rPr>
-              <a:t>Kernel size</a:t>
-            </a:r>
-            <a:endParaRPr lang="en-US" sz="1500" dirty="0"/>
-          </a:p>
-        </p:txBody>
-      </p:sp>
-      <p:sp>
-        <p:nvSpPr>
-          <p:cNvPr id="14" name="Text 12"/>
-          <p:cNvSpPr txBox="1"/>
-          <p:nvPr/>
-        </p:nvSpPr>
-        <p:spPr>
-          <a:xfrm>
-            <a:off x="1005840" y="3182112"/>
-            <a:ext cx="3291840" cy="566928"/>
-          </a:xfrm>
-          <a:prstGeom prst="rect">
-            <a:avLst/>
-          </a:prstGeom>
-          <a:noFill/>
-          <a:ln/>
-        </p:spPr>
-        <p:txBody>
-          <a:bodyPr wrap="square" lIns="0" tIns="0" rIns="0" bIns="0" rtlCol="0" anchor="t"/>
-          <a:lstStyle/>
-          <a:p>
-            <a:pPr indent="0" marL="0">
-              <a:buNone/>
-            </a:pPr>
-            <a:r>
-              <a:rPr lang="en-US" sz="1200" dirty="0">
-                <a:solidFill>
-                  <a:schemeClr val="tx2"/>
-                </a:solidFill>
-              </a:rPr>
-              <a:t>2×5 tile: 10 acc + 2 weights + 1 broadcast = 13 regs; 7 loads per 10 FMAs; 5 divides every width.</a:t>
-            </a:r>
-            <a:endParaRPr lang="en-US" sz="1200" dirty="0"/>
-          </a:p>
-        </p:txBody>
-      </p:sp>
-      <p:sp>
-        <p:nvSpPr>
-          <p:cNvPr id="15" name="step-4"/>
-          <p:cNvSpPr/>
-          <p:nvPr/>
-        </p:nvSpPr>
-        <p:spPr>
-          <a:xfrm>
-            <a:off x="457200" y="3803904"/>
-            <a:ext cx="384048" cy="384048"/>
-          </a:xfrm>
-          <a:prstGeom prst="ellipse">
-            <a:avLst/>
-          </a:prstGeom>
-          <a:solidFill>
-            <a:srgbClr val="0C6A87"/>
-          </a:solidFill>
-          <a:ln w="12700">
-            <a:solidFill>
-              <a:srgbClr val="0C6A87"/>
-            </a:solidFill>
-            <a:prstDash val="solid"/>
-          </a:ln>
-        </p:spPr>
-      </p:sp>
-      <p:sp>
-        <p:nvSpPr>
-          <p:cNvPr id="16" name="Text 14"/>
-          <p:cNvSpPr txBox="1"/>
-          <p:nvPr/>
-        </p:nvSpPr>
-        <p:spPr>
-          <a:xfrm>
-            <a:off x="457200" y="3803904"/>
-            <a:ext cx="384048" cy="384048"/>
-          </a:xfrm>
-          <a:prstGeom prst="rect">
-            <a:avLst/>
-          </a:prstGeom>
-          <a:noFill/>
-          <a:ln/>
-        </p:spPr>
-        <p:txBody>
-          <a:bodyPr wrap="square" lIns="0" tIns="0" rIns="0" bIns="0" rtlCol="0" anchor="ctr"/>
-          <a:lstStyle/>
-          <a:p>
-            <a:pPr algn="ctr" indent="0" marL="0">
-              <a:buNone/>
-            </a:pPr>
-            <a:r>
-              <a:rPr lang="en-US" sz="1600" b="1" dirty="0">
-                <a:solidFill>
-                  <a:schemeClr val="bg1"/>
-                </a:solidFill>
-              </a:rPr>
-              <a:t>4</a:t>
-            </a:r>
-            <a:endParaRPr lang="en-US" sz="1600" dirty="0"/>
-          </a:p>
-        </p:txBody>
-      </p:sp>
-      <p:sp>
-        <p:nvSpPr>
-          <p:cNvPr id="17" name="Text 15"/>
-          <p:cNvSpPr txBox="1"/>
-          <p:nvPr/>
-        </p:nvSpPr>
-        <p:spPr>
-          <a:xfrm>
-            <a:off x="1005840" y="3785616"/>
-            <a:ext cx="3291840" cy="274320"/>
-          </a:xfrm>
-          <a:prstGeom prst="rect">
-            <a:avLst/>
-          </a:prstGeom>
-          <a:noFill/>
-          <a:ln/>
-        </p:spPr>
-        <p:txBody>
-          <a:bodyPr wrap="square" lIns="0" tIns="0" rIns="0" bIns="0" rtlCol="0" anchor="t"/>
-          <a:lstStyle/>
-          <a:p>
-            <a:pPr indent="0" marL="0">
-              <a:buNone/>
-            </a:pPr>
-            <a:r>
-              <a:rPr lang="en-US" sz="1500" b="1" dirty="0">
-                <a:solidFill>
-                  <a:schemeClr val="tx1"/>
-                </a:solidFill>
-              </a:rPr>
-              <a:t>Benchmark like A2</a:t>
-            </a:r>
-            <a:endParaRPr lang="en-US" sz="1500" dirty="0"/>
-          </a:p>
-        </p:txBody>
-      </p:sp>
-      <p:sp>
-        <p:nvSpPr>
-          <p:cNvPr id="18" name="Text 16"/>
-          <p:cNvSpPr txBox="1"/>
-          <p:nvPr/>
-        </p:nvSpPr>
-        <p:spPr>
-          <a:xfrm>
-            <a:off x="1005840" y="4078224"/>
-            <a:ext cx="3291840" cy="566928"/>
-          </a:xfrm>
-          <a:prstGeom prst="rect">
-            <a:avLst/>
-          </a:prstGeom>
-          <a:noFill/>
-          <a:ln/>
-        </p:spPr>
-        <p:txBody>
-          <a:bodyPr wrap="square" lIns="0" tIns="0" rIns="0" bIns="0" rtlCol="0" anchor="t"/>
-          <a:lstStyle/>
-          <a:p>
-            <a:pPr indent="0" marL="0">
-              <a:buNone/>
-            </a:pPr>
-            <a:r>
-              <a:rPr lang="en-US" sz="1200" dirty="0">
-                <a:solidFill>
-                  <a:schemeClr val="tx2"/>
-                </a:solidFill>
-              </a:rPr>
-              <a:t>Microkernel alone, k = 72 to 4608, 3 runs, 2 s warm-up, core cycles, checked vs a reference.</a:t>
-            </a:r>
-            <a:endParaRPr lang="en-US" sz="1200" dirty="0"/>
-          </a:p>
-        </p:txBody>
-      </p:sp>
-      <p:graphicFrame>
-        <p:nvGraphicFramePr>
-          <p:cNvPr id="19" name="accumulator-chart" descr=""/>
-          <p:cNvGraphicFramePr/>
-          <p:nvPr/>
-        </p:nvGraphicFramePr>
-        <p:xfrm>
-          <a:off x="4572000" y="960120"/>
-          <a:ext cx="4160520" cy="3611880"/>
-        </p:xfrm>
-        <a:graphic xmlns:a="http://schemas.openxmlformats.org/drawingml/2006/main">
-          <a:graphicData uri="http://schemas.openxmlformats.org/drawingml/2006/chart">
-            <c:chart xmlns:c="http://schemas.openxmlformats.org/drawingml/2006/chart" r:id="rId1"/>
-          </a:graphicData>
-        </a:graphic>
-      </p:graphicFrame>
       <p:sp>
         <p:nvSpPr>
           <p:cNvPr id="25" name="Slide Number Placeholder 0"/>
@@ -6283,58 +4893,32 @@
                   <a:schemeClr val="tx1"/>
                 </a:solidFill>
               </a:rPr>
-              <a:t>Same math, 50% to 95%: tile and register allocation</a:t>
+              <a:t>Four steps: ops → accumulators → tile → benchmark</a:t>
             </a:r>
             <a:endParaRPr lang="en-US" sz="2600" dirty="0"/>
           </a:p>
         </p:txBody>
       </p:sp>
-      <p:pic>
-        <p:nvPicPr>
-          <p:cNvPr id="3" name="Image 0" descr="Design space: percent of peak for every stride-1 kernel, alone and in all 32 layers">    </p:cNvPr>
-          <p:cNvPicPr>
-            <a:picLocks noChangeAspect="1"/>
-          </p:cNvPicPr>
-          <p:nvPr/>
-        </p:nvPicPr>
-        <p:blipFill>
-          <a:blip r:embed="rId1"/>
-          <a:stretch>
-            <a:fillRect/>
-          </a:stretch>
-        </p:blipFill>
-        <p:spPr>
-          <a:xfrm>
-            <a:off x="457200" y="914400"/>
-            <a:ext cx="6858000" cy="3730752"/>
-          </a:xfrm>
-          <a:prstGeom prst="rect">
-            <a:avLst/>
-          </a:prstGeom>
-        </p:spPr>
-      </p:pic>
-      <p:sp>
-        <p:nvSpPr>
-          <p:cNvPr id="4" name="ds-card-0"/>
+      <p:sp>
+        <p:nvSpPr>
+          <p:cNvPr id="3" name="step-1"/>
           <p:cNvSpPr/>
           <p:nvPr/>
         </p:nvSpPr>
         <p:spPr>
           <a:xfrm>
-            <a:off x="7452360" y="960120"/>
-            <a:ext cx="1280160" cy="1143000"/>
-          </a:xfrm>
-          <a:prstGeom prst="roundRect">
-            <a:avLst>
-              <a:gd name="adj" fmla="val 6400"/>
-            </a:avLst>
+            <a:off x="457200" y="1115568"/>
+            <a:ext cx="384048" cy="384048"/>
+          </a:xfrm>
+          <a:prstGeom prst="ellipse">
+            <a:avLst/>
           </a:prstGeom>
           <a:solidFill>
-            <a:srgbClr val="EEF2F4"/>
+            <a:srgbClr val="0C6A87"/>
           </a:solidFill>
           <a:ln w="12700">
             <a:solidFill>
-              <a:srgbClr val="EEF2F4"/>
+              <a:srgbClr val="0C6A87"/>
             </a:solidFill>
             <a:prstDash val="solid"/>
           </a:ln>
@@ -6342,14 +4926,50 @@
       </p:sp>
       <p:sp>
         <p:nvSpPr>
-          <p:cNvPr id="5" name="Text 2"/>
+          <p:cNvPr id="4" name="Text 2"/>
           <p:cNvSpPr txBox="1"/>
           <p:nvPr/>
         </p:nvSpPr>
         <p:spPr>
           <a:xfrm>
-            <a:off x="7543800" y="1033272"/>
-            <a:ext cx="1115568" cy="274320"/>
+            <a:off x="457200" y="1115568"/>
+            <a:ext cx="384048" cy="384048"/>
+          </a:xfrm>
+          <a:prstGeom prst="rect">
+            <a:avLst/>
+          </a:prstGeom>
+          <a:noFill/>
+          <a:ln/>
+        </p:spPr>
+        <p:txBody>
+          <a:bodyPr wrap="square" lIns="0" tIns="0" rIns="0" bIns="0" rtlCol="0" anchor="ctr"/>
+          <a:lstStyle/>
+          <a:p>
+            <a:pPr algn="ctr" indent="0" marL="0">
+              <a:buNone/>
+            </a:pPr>
+            <a:r>
+              <a:rPr lang="en-US" sz="1600" b="1" dirty="0">
+                <a:solidFill>
+                  <a:schemeClr val="bg1"/>
+                </a:solidFill>
+              </a:rPr>
+              <a:t>1</a:t>
+            </a:r>
+            <a:endParaRPr lang="en-US" sz="1600" dirty="0"/>
+          </a:p>
+        </p:txBody>
+      </p:sp>
+      <p:sp>
+        <p:nvSpPr>
+          <p:cNvPr id="5" name="Text 3"/>
+          <p:cNvSpPr txBox="1"/>
+          <p:nvPr/>
+        </p:nvSpPr>
+        <p:spPr>
+          <a:xfrm>
+            <a:off x="1005840" y="1097280"/>
+            <a:ext cx="3291840" cy="274320"/>
           </a:xfrm>
           <a:prstGeom prst="rect">
             <a:avLst/>
@@ -6365,27 +4985,27 @@
               <a:buNone/>
             </a:pPr>
             <a:r>
-              <a:rPr lang="en-US" sz="1200" b="1" dirty="0">
+              <a:rPr lang="en-US" sz="1500" b="1" dirty="0">
                 <a:solidFill>
                   <a:schemeClr val="tx1"/>
                 </a:solidFill>
               </a:rPr>
-              <a:t>Intrinsics</a:t>
-            </a:r>
-            <a:endParaRPr lang="en-US" sz="1200" dirty="0"/>
-          </a:p>
-        </p:txBody>
-      </p:sp>
-      <p:sp>
-        <p:nvSpPr>
-          <p:cNvPr id="6" name="Text 3"/>
+              <a:t>Independent ops</a:t>
+            </a:r>
+            <a:endParaRPr lang="en-US" sz="1500" dirty="0"/>
+          </a:p>
+        </p:txBody>
+      </p:sp>
+      <p:sp>
+        <p:nvSpPr>
+          <p:cNvPr id="6" name="Text 4"/>
           <p:cNvSpPr txBox="1"/>
           <p:nvPr/>
         </p:nvSpPr>
         <p:spPr>
           <a:xfrm>
-            <a:off x="7543800" y="1325880"/>
-            <a:ext cx="1115568" cy="749808"/>
+            <a:off x="1005840" y="1389888"/>
+            <a:ext cx="3291840" cy="566928"/>
           </a:xfrm>
           <a:prstGeom prst="rect">
             <a:avLst/>
@@ -6401,39 +5021,37 @@
               <a:buNone/>
             </a:pPr>
             <a:r>
-              <a:rPr lang="en-US" sz="1100" dirty="0">
+              <a:rPr lang="en-US" sz="1200" dirty="0">
                 <a:solidFill>
                   <a:schemeClr val="tx2"/>
                 </a:solidFill>
               </a:rPr>
-              <a:t>GCC: clean at 13 regs, copies at 15, spills at 16</a:t>
-            </a:r>
-            <a:endParaRPr lang="en-US" sz="1100" dirty="0"/>
-          </a:p>
-        </p:txBody>
-      </p:sp>
-      <p:sp>
-        <p:nvSpPr>
-          <p:cNvPr id="7" name="ds-card-1"/>
+              <a:t>Every output is its own dot product of length C × 9: 102,400 in a 40×40, 64-channel layer.</a:t>
+            </a:r>
+            <a:endParaRPr lang="en-US" sz="1200" dirty="0"/>
+          </a:p>
+        </p:txBody>
+      </p:sp>
+      <p:sp>
+        <p:nvSpPr>
+          <p:cNvPr id="7" name="step-2"/>
           <p:cNvSpPr/>
           <p:nvPr/>
         </p:nvSpPr>
         <p:spPr>
           <a:xfrm>
-            <a:off x="7452360" y="2212848"/>
-            <a:ext cx="1280160" cy="1143000"/>
-          </a:xfrm>
-          <a:prstGeom prst="roundRect">
-            <a:avLst>
-              <a:gd name="adj" fmla="val 6400"/>
-            </a:avLst>
+            <a:off x="457200" y="2011680"/>
+            <a:ext cx="384048" cy="384048"/>
+          </a:xfrm>
+          <a:prstGeom prst="ellipse">
+            <a:avLst/>
           </a:prstGeom>
           <a:solidFill>
-            <a:srgbClr val="D7EAF0"/>
+            <a:srgbClr val="0C6A87"/>
           </a:solidFill>
           <a:ln w="12700">
             <a:solidFill>
-              <a:srgbClr val="D7EAF0"/>
+              <a:srgbClr val="0C6A87"/>
             </a:solidFill>
             <a:prstDash val="solid"/>
           </a:ln>
@@ -6441,14 +5059,50 @@
       </p:sp>
       <p:sp>
         <p:nvSpPr>
-          <p:cNvPr id="8" name="Text 5"/>
+          <p:cNvPr id="8" name="Text 6"/>
           <p:cNvSpPr txBox="1"/>
           <p:nvPr/>
         </p:nvSpPr>
         <p:spPr>
           <a:xfrm>
-            <a:off x="7543800" y="2286000"/>
-            <a:ext cx="1115568" cy="274320"/>
+            <a:off x="457200" y="2011680"/>
+            <a:ext cx="384048" cy="384048"/>
+          </a:xfrm>
+          <a:prstGeom prst="rect">
+            <a:avLst/>
+          </a:prstGeom>
+          <a:noFill/>
+          <a:ln/>
+        </p:spPr>
+        <p:txBody>
+          <a:bodyPr wrap="square" lIns="0" tIns="0" rIns="0" bIns="0" rtlCol="0" anchor="ctr"/>
+          <a:lstStyle/>
+          <a:p>
+            <a:pPr algn="ctr" indent="0" marL="0">
+              <a:buNone/>
+            </a:pPr>
+            <a:r>
+              <a:rPr lang="en-US" sz="1600" b="1" dirty="0">
+                <a:solidFill>
+                  <a:schemeClr val="bg1"/>
+                </a:solidFill>
+              </a:rPr>
+              <a:t>2</a:t>
+            </a:r>
+            <a:endParaRPr lang="en-US" sz="1600" dirty="0"/>
+          </a:p>
+        </p:txBody>
+      </p:sp>
+      <p:sp>
+        <p:nvSpPr>
+          <p:cNvPr id="9" name="Text 7"/>
+          <p:cNvSpPr txBox="1"/>
+          <p:nvPr/>
+        </p:nvSpPr>
+        <p:spPr>
+          <a:xfrm>
+            <a:off x="1005840" y="1993392"/>
+            <a:ext cx="3291840" cy="274320"/>
           </a:xfrm>
           <a:prstGeom prst="rect">
             <a:avLst/>
@@ -6464,27 +5118,27 @@
               <a:buNone/>
             </a:pPr>
             <a:r>
-              <a:rPr lang="en-US" sz="1200" b="1" dirty="0">
-                <a:solidFill>
-                  <a:schemeClr val="accent1"/>
+              <a:rPr lang="en-US" sz="1500" b="1" dirty="0">
+                <a:solidFill>
+                  <a:schemeClr val="tx1"/>
                 </a:solidFill>
               </a:rPr>
-              <a:t>Inline asm</a:t>
-            </a:r>
-            <a:endParaRPr lang="en-US" sz="1200" dirty="0"/>
-          </a:p>
-        </p:txBody>
-      </p:sp>
-      <p:sp>
-        <p:nvSpPr>
-          <p:cNvPr id="9" name="Text 6"/>
+              <a:t>Outputs in flight</a:t>
+            </a:r>
+            <a:endParaRPr lang="en-US" sz="1500" dirty="0"/>
+          </a:p>
+        </p:txBody>
+      </p:sp>
+      <p:sp>
+        <p:nvSpPr>
+          <p:cNvPr id="10" name="Text 8"/>
           <p:cNvSpPr txBox="1"/>
           <p:nvPr/>
         </p:nvSpPr>
         <p:spPr>
           <a:xfrm>
-            <a:off x="7543800" y="2578608"/>
-            <a:ext cx="1115568" cy="749808"/>
+            <a:off x="1005840" y="2286000"/>
+            <a:ext cx="3291840" cy="566928"/>
           </a:xfrm>
           <a:prstGeom prst="rect">
             <a:avLst/>
@@ -6500,39 +5154,37 @@
               <a:buNone/>
             </a:pPr>
             <a:r>
-              <a:rPr lang="en-US" sz="1100" dirty="0">
+              <a:rPr lang="en-US" sz="1200" dirty="0">
                 <a:solidFill>
                   <a:schemeClr val="tx2"/>
                 </a:solidFill>
               </a:rPr>
-              <a:t>2×6 by hand: 94.5% alone, 84% in layers</a:t>
-            </a:r>
-            <a:endParaRPr lang="en-US" sz="1100" dirty="0"/>
-          </a:p>
-        </p:txBody>
-      </p:sp>
-      <p:sp>
-        <p:nvSpPr>
-          <p:cNvPr id="10" name="ds-card-2"/>
+              <a:t>Latency 5 × 2 FMA/cycle = 10 accumulators; 1 accumulator runs at exactly 10% of peak.</a:t>
+            </a:r>
+            <a:endParaRPr lang="en-US" sz="1200" dirty="0"/>
+          </a:p>
+        </p:txBody>
+      </p:sp>
+      <p:sp>
+        <p:nvSpPr>
+          <p:cNvPr id="11" name="step-3"/>
           <p:cNvSpPr/>
           <p:nvPr/>
         </p:nvSpPr>
         <p:spPr>
           <a:xfrm>
-            <a:off x="7452360" y="3465576"/>
-            <a:ext cx="1280160" cy="1143000"/>
-          </a:xfrm>
-          <a:prstGeom prst="roundRect">
-            <a:avLst>
-              <a:gd name="adj" fmla="val 6400"/>
-            </a:avLst>
+            <a:off x="457200" y="2907792"/>
+            <a:ext cx="384048" cy="384048"/>
+          </a:xfrm>
+          <a:prstGeom prst="ellipse">
+            <a:avLst/>
           </a:prstGeom>
           <a:solidFill>
-            <a:srgbClr val="EEF2F4"/>
+            <a:srgbClr val="0C6A87"/>
           </a:solidFill>
           <a:ln w="12700">
             <a:solidFill>
-              <a:srgbClr val="EEF2F4"/>
+              <a:srgbClr val="0C6A87"/>
             </a:solidFill>
             <a:prstDash val="solid"/>
           </a:ln>
@@ -6540,14 +5192,50 @@
       </p:sp>
       <p:sp>
         <p:nvSpPr>
-          <p:cNvPr id="11" name="Text 8"/>
+          <p:cNvPr id="12" name="Text 10"/>
           <p:cNvSpPr txBox="1"/>
           <p:nvPr/>
         </p:nvSpPr>
         <p:spPr>
           <a:xfrm>
-            <a:off x="7543800" y="3538728"/>
-            <a:ext cx="1115568" cy="274320"/>
+            <a:off x="457200" y="2907792"/>
+            <a:ext cx="384048" cy="384048"/>
+          </a:xfrm>
+          <a:prstGeom prst="rect">
+            <a:avLst/>
+          </a:prstGeom>
+          <a:noFill/>
+          <a:ln/>
+        </p:spPr>
+        <p:txBody>
+          <a:bodyPr wrap="square" lIns="0" tIns="0" rIns="0" bIns="0" rtlCol="0" anchor="ctr"/>
+          <a:lstStyle/>
+          <a:p>
+            <a:pPr algn="ctr" indent="0" marL="0">
+              <a:buNone/>
+            </a:pPr>
+            <a:r>
+              <a:rPr lang="en-US" sz="1600" b="1" dirty="0">
+                <a:solidFill>
+                  <a:schemeClr val="bg1"/>
+                </a:solidFill>
+              </a:rPr>
+              <a:t>3</a:t>
+            </a:r>
+            <a:endParaRPr lang="en-US" sz="1600" dirty="0"/>
+          </a:p>
+        </p:txBody>
+      </p:sp>
+      <p:sp>
+        <p:nvSpPr>
+          <p:cNvPr id="13" name="Text 11"/>
+          <p:cNvSpPr txBox="1"/>
+          <p:nvPr/>
+        </p:nvSpPr>
+        <p:spPr>
+          <a:xfrm>
+            <a:off x="1005840" y="2889504"/>
+            <a:ext cx="3291840" cy="274320"/>
           </a:xfrm>
           <a:prstGeom prst="rect">
             <a:avLst/>
@@ -6563,27 +5251,27 @@
               <a:buNone/>
             </a:pPr>
             <a:r>
-              <a:rPr lang="en-US" sz="1200" b="1" dirty="0">
+              <a:rPr lang="en-US" sz="1500" b="1" dirty="0">
                 <a:solidFill>
                   <a:schemeClr val="tx1"/>
                 </a:solidFill>
               </a:rPr>
-              <a:t>Unroll, pipeline</a:t>
-            </a:r>
-            <a:endParaRPr lang="en-US" sz="1200" dirty="0"/>
-          </a:p>
-        </p:txBody>
-      </p:sp>
-      <p:sp>
-        <p:nvSpPr>
-          <p:cNvPr id="12" name="Text 9"/>
+              <a:t>Kernel size</a:t>
+            </a:r>
+            <a:endParaRPr lang="en-US" sz="1500" dirty="0"/>
+          </a:p>
+        </p:txBody>
+      </p:sp>
+      <p:sp>
+        <p:nvSpPr>
+          <p:cNvPr id="14" name="Text 12"/>
           <p:cNvSpPr txBox="1"/>
           <p:nvPr/>
         </p:nvSpPr>
         <p:spPr>
           <a:xfrm>
-            <a:off x="7543800" y="3831336"/>
-            <a:ext cx="1115568" cy="749808"/>
+            <a:off x="1005840" y="3182112"/>
+            <a:ext cx="3291840" cy="566928"/>
           </a:xfrm>
           <a:prstGeom prst="rect">
             <a:avLst/>
@@ -6599,17 +5287,166 @@
               <a:buNone/>
             </a:pPr>
             <a:r>
-              <a:rPr lang="en-US" sz="1100" dirty="0">
+              <a:rPr lang="en-US" sz="1200" dirty="0">
                 <a:solidFill>
                   <a:schemeClr val="tx2"/>
                 </a:solidFill>
               </a:rPr>
-              <a:t>lost: uop cache, spills</a:t>
-            </a:r>
-            <a:endParaRPr lang="en-US" sz="1100" dirty="0"/>
-          </a:p>
-        </p:txBody>
-      </p:sp>
+              <a:t>2×5 tile: 10 acc + 2 weights + 1 broadcast = 13 regs; 7 loads per 10 FMAs; 5 divides every width.</a:t>
+            </a:r>
+            <a:endParaRPr lang="en-US" sz="1200" dirty="0"/>
+          </a:p>
+        </p:txBody>
+      </p:sp>
+      <p:sp>
+        <p:nvSpPr>
+          <p:cNvPr id="15" name="step-4"/>
+          <p:cNvSpPr/>
+          <p:nvPr/>
+        </p:nvSpPr>
+        <p:spPr>
+          <a:xfrm>
+            <a:off x="457200" y="3803904"/>
+            <a:ext cx="384048" cy="384048"/>
+          </a:xfrm>
+          <a:prstGeom prst="ellipse">
+            <a:avLst/>
+          </a:prstGeom>
+          <a:solidFill>
+            <a:srgbClr val="0C6A87"/>
+          </a:solidFill>
+          <a:ln w="12700">
+            <a:solidFill>
+              <a:srgbClr val="0C6A87"/>
+            </a:solidFill>
+            <a:prstDash val="solid"/>
+          </a:ln>
+        </p:spPr>
+      </p:sp>
+      <p:sp>
+        <p:nvSpPr>
+          <p:cNvPr id="16" name="Text 14"/>
+          <p:cNvSpPr txBox="1"/>
+          <p:nvPr/>
+        </p:nvSpPr>
+        <p:spPr>
+          <a:xfrm>
+            <a:off x="457200" y="3803904"/>
+            <a:ext cx="384048" cy="384048"/>
+          </a:xfrm>
+          <a:prstGeom prst="rect">
+            <a:avLst/>
+          </a:prstGeom>
+          <a:noFill/>
+          <a:ln/>
+        </p:spPr>
+        <p:txBody>
+          <a:bodyPr wrap="square" lIns="0" tIns="0" rIns="0" bIns="0" rtlCol="0" anchor="ctr"/>
+          <a:lstStyle/>
+          <a:p>
+            <a:pPr algn="ctr" indent="0" marL="0">
+              <a:buNone/>
+            </a:pPr>
+            <a:r>
+              <a:rPr lang="en-US" sz="1600" b="1" dirty="0">
+                <a:solidFill>
+                  <a:schemeClr val="bg1"/>
+                </a:solidFill>
+              </a:rPr>
+              <a:t>4</a:t>
+            </a:r>
+            <a:endParaRPr lang="en-US" sz="1600" dirty="0"/>
+          </a:p>
+        </p:txBody>
+      </p:sp>
+      <p:sp>
+        <p:nvSpPr>
+          <p:cNvPr id="17" name="Text 15"/>
+          <p:cNvSpPr txBox="1"/>
+          <p:nvPr/>
+        </p:nvSpPr>
+        <p:spPr>
+          <a:xfrm>
+            <a:off x="1005840" y="3785616"/>
+            <a:ext cx="3291840" cy="274320"/>
+          </a:xfrm>
+          <a:prstGeom prst="rect">
+            <a:avLst/>
+          </a:prstGeom>
+          <a:noFill/>
+          <a:ln/>
+        </p:spPr>
+        <p:txBody>
+          <a:bodyPr wrap="square" lIns="0" tIns="0" rIns="0" bIns="0" rtlCol="0" anchor="t"/>
+          <a:lstStyle/>
+          <a:p>
+            <a:pPr indent="0" marL="0">
+              <a:buNone/>
+            </a:pPr>
+            <a:r>
+              <a:rPr lang="en-US" sz="1500" b="1" dirty="0">
+                <a:solidFill>
+                  <a:schemeClr val="tx1"/>
+                </a:solidFill>
+              </a:rPr>
+              <a:t>Benchmark like A2</a:t>
+            </a:r>
+            <a:endParaRPr lang="en-US" sz="1500" dirty="0"/>
+          </a:p>
+        </p:txBody>
+      </p:sp>
+      <p:sp>
+        <p:nvSpPr>
+          <p:cNvPr id="18" name="Text 16"/>
+          <p:cNvSpPr txBox="1"/>
+          <p:nvPr/>
+        </p:nvSpPr>
+        <p:spPr>
+          <a:xfrm>
+            <a:off x="1005840" y="4078224"/>
+            <a:ext cx="3291840" cy="566928"/>
+          </a:xfrm>
+          <a:prstGeom prst="rect">
+            <a:avLst/>
+          </a:prstGeom>
+          <a:noFill/>
+          <a:ln/>
+        </p:spPr>
+        <p:txBody>
+          <a:bodyPr wrap="square" lIns="0" tIns="0" rIns="0" bIns="0" rtlCol="0" anchor="t"/>
+          <a:lstStyle/>
+          <a:p>
+            <a:pPr indent="0" marL="0">
+              <a:buNone/>
+            </a:pPr>
+            <a:r>
+              <a:rPr lang="en-US" sz="1200" dirty="0">
+                <a:solidFill>
+                  <a:schemeClr val="tx2"/>
+                </a:solidFill>
+              </a:rPr>
+              <a:t>Microkernel alone, k = 72 to 4608, 3 runs, 2 s warm-up, core cycles, checked vs a reference.</a:t>
+            </a:r>
+            <a:endParaRPr lang="en-US" sz="1200" dirty="0"/>
+          </a:p>
+        </p:txBody>
+      </p:sp>
+      <p:graphicFrame>
+        <p:nvGraphicFramePr>
+          <p:cNvPr id="19" name="accumulator-chart" descr=""/>
+          <p:cNvGraphicFramePr/>
+          <p:nvPr/>
+        </p:nvGraphicFramePr>
+        <p:xfrm>
+          <a:off x="4572000" y="960120"/>
+          <a:ext cx="4160520" cy="3611880"/>
+        </p:xfrm>
+        <a:graphic xmlns:a="http://schemas.openxmlformats.org/drawingml/2006/main">
+          <a:graphicData uri="http://schemas.openxmlformats.org/drawingml/2006/chart">
+            <c:chart xmlns:c="http://schemas.openxmlformats.org/drawingml/2006/chart" r:id="rId1"/>
+          </a:graphicData>
+        </a:graphic>
+      </p:graphicFrame>
       <p:sp>
         <p:nvSpPr>
           <p:cNvPr id="25" name="Slide Number Placeholder 0"/>
@@ -6712,7 +5549,7 @@
                   <a:schemeClr val="tx1"/>
                 </a:solidFill>
               </a:rPr>
-              <a:t>Benchmarked like Assignment 2: FLOPs/cycle vs k</a:t>
+              <a:t>Same math, 50% to 95%: tile and register allocation</a:t>
             </a:r>
             <a:endParaRPr lang="en-US" sz="2600" dirty="0"/>
           </a:p>
@@ -6720,7 +5557,7 @@
       </p:sp>
       <p:pic>
         <p:nvPicPr>
-          <p:cNvPr id="3" name="Image 0" descr="FLOPs per cycle vs k for the 2x5, 2x6 and 2x6 asm microkernels with SiLU off">    </p:cNvPr>
+          <p:cNvPr id="3" name="Image 0" descr="Design space: percent of peak for every stride-1 kernel, alone and in all 32 layers">    </p:cNvPr>
           <p:cNvPicPr>
             <a:picLocks noChangeAspect="1"/>
           </p:cNvPicPr>
@@ -6735,7 +5572,7 @@
         <p:spPr>
           <a:xfrm>
             <a:off x="457200" y="914400"/>
-            <a:ext cx="5943600" cy="3172968"/>
+            <a:ext cx="6858000" cy="3730752"/>
           </a:xfrm>
           <a:prstGeom prst="rect">
             <a:avLst/>
@@ -6744,14 +5581,41 @@
       </p:pic>
       <p:sp>
         <p:nvSpPr>
-          <p:cNvPr id="4" name="Text 1"/>
+          <p:cNvPr id="4" name="ds-card-0"/>
+          <p:cNvSpPr/>
+          <p:nvPr/>
+        </p:nvSpPr>
+        <p:spPr>
+          <a:xfrm>
+            <a:off x="7452360" y="960120"/>
+            <a:ext cx="1280160" cy="1143000"/>
+          </a:xfrm>
+          <a:prstGeom prst="roundRect">
+            <a:avLst>
+              <a:gd name="adj" fmla="val 6400"/>
+            </a:avLst>
+          </a:prstGeom>
+          <a:solidFill>
+            <a:srgbClr val="EEF2F4"/>
+          </a:solidFill>
+          <a:ln w="12700">
+            <a:solidFill>
+              <a:srgbClr val="EEF2F4"/>
+            </a:solidFill>
+            <a:prstDash val="solid"/>
+          </a:ln>
+        </p:spPr>
+      </p:sp>
+      <p:sp>
+        <p:nvSpPr>
+          <p:cNvPr id="5" name="Text 2"/>
           <p:cNvSpPr txBox="1"/>
           <p:nvPr/>
         </p:nvSpPr>
         <p:spPr>
           <a:xfrm>
-            <a:off x="457200" y="4160520"/>
-            <a:ext cx="5943600" cy="457200"/>
+            <a:off x="7543800" y="1033272"/>
+            <a:ext cx="1115568" cy="274320"/>
           </a:xfrm>
           <a:prstGeom prst="rect">
             <a:avLst/>
@@ -6767,12 +5631,12 @@
               <a:buNone/>
             </a:pPr>
             <a:r>
-              <a:rPr lang="en-US" sz="1200" dirty="0">
-                <a:solidFill>
-                  <a:schemeClr val="tx2"/>
+              <a:rPr lang="en-US" sz="1200" b="1" dirty="0">
+                <a:solidFill>
+                  <a:schemeClr val="tx1"/>
                 </a:solidFill>
               </a:rPr>
-              <a:t>SiLU off: the pure convolution, as in A2. 3 runs, core cycles, every point checked (576 pass).</a:t>
+              <a:t>Intrinsics</a:t>
             </a:r>
             <a:endParaRPr lang="en-US" sz="1200" dirty="0"/>
           </a:p>
@@ -6780,14 +5644,14 @@
       </p:sp>
       <p:sp>
         <p:nvSpPr>
-          <p:cNvPr id="5" name="Text 2"/>
+          <p:cNvPr id="6" name="Text 3"/>
           <p:cNvSpPr txBox="1"/>
           <p:nvPr/>
         </p:nvSpPr>
         <p:spPr>
           <a:xfrm>
-            <a:off x="6675120" y="960120"/>
-            <a:ext cx="2057400" cy="685800"/>
+            <a:off x="7543800" y="1325880"/>
+            <a:ext cx="1115568" cy="749808"/>
           </a:xfrm>
           <a:prstGeom prst="rect">
             <a:avLst/>
@@ -6803,30 +5667,54 @@
               <a:buNone/>
             </a:pPr>
             <a:r>
-              <a:rPr lang="en-US" sz="4000" b="1" dirty="0">
-                <a:solidFill>
-                  <a:schemeClr val="accent1"/>
-                </a:solidFill>
-                <a:latin typeface="Cambria" pitchFamily="34" charset="0"/>
-                <a:ea typeface="Cambria" pitchFamily="34" charset="-122"/>
-                <a:cs typeface="Cambria" pitchFamily="34" charset="-120"/>
+              <a:rPr lang="en-US" sz="1100" dirty="0">
+                <a:solidFill>
+                  <a:schemeClr val="tx2"/>
+                </a:solidFill>
               </a:rPr>
-              <a:t>94–98%</a:t>
-            </a:r>
-            <a:endParaRPr lang="en-US" sz="4000" dirty="0"/>
-          </a:p>
-        </p:txBody>
-      </p:sp>
-      <p:sp>
-        <p:nvSpPr>
-          <p:cNvPr id="6" name="Text 3"/>
+              <a:t>GCC: clean at 13 regs, copies at 15, spills at 16</a:t>
+            </a:r>
+            <a:endParaRPr lang="en-US" sz="1100" dirty="0"/>
+          </a:p>
+        </p:txBody>
+      </p:sp>
+      <p:sp>
+        <p:nvSpPr>
+          <p:cNvPr id="7" name="ds-card-1"/>
+          <p:cNvSpPr/>
+          <p:nvPr/>
+        </p:nvSpPr>
+        <p:spPr>
+          <a:xfrm>
+            <a:off x="7452360" y="2212848"/>
+            <a:ext cx="1280160" cy="1143000"/>
+          </a:xfrm>
+          <a:prstGeom prst="roundRect">
+            <a:avLst>
+              <a:gd name="adj" fmla="val 6400"/>
+            </a:avLst>
+          </a:prstGeom>
+          <a:solidFill>
+            <a:srgbClr val="D7EAF0"/>
+          </a:solidFill>
+          <a:ln w="12700">
+            <a:solidFill>
+              <a:srgbClr val="D7EAF0"/>
+            </a:solidFill>
+            <a:prstDash val="solid"/>
+          </a:ln>
+        </p:spPr>
+      </p:sp>
+      <p:sp>
+        <p:nvSpPr>
+          <p:cNvPr id="8" name="Text 5"/>
           <p:cNvSpPr txBox="1"/>
           <p:nvPr/>
         </p:nvSpPr>
         <p:spPr>
           <a:xfrm>
-            <a:off x="6675120" y="1673352"/>
-            <a:ext cx="2057400" cy="548640"/>
+            <a:off x="7543800" y="2286000"/>
+            <a:ext cx="1115568" cy="274320"/>
           </a:xfrm>
           <a:prstGeom prst="rect">
             <a:avLst/>
@@ -6842,27 +5730,27 @@
               <a:buNone/>
             </a:pPr>
             <a:r>
-              <a:rPr lang="en-US" sz="1300" dirty="0">
-                <a:solidFill>
-                  <a:schemeClr val="tx2"/>
+              <a:rPr lang="en-US" sz="1200" b="1" dirty="0">
+                <a:solidFill>
+                  <a:schemeClr val="accent1"/>
                 </a:solidFill>
               </a:rPr>
-              <a:t>2×6 asm: 30–31 FLOPs/cycle, 96 GFLOP/s on one core</a:t>
-            </a:r>
-            <a:endParaRPr lang="en-US" sz="1300" dirty="0"/>
-          </a:p>
-        </p:txBody>
-      </p:sp>
-      <p:sp>
-        <p:nvSpPr>
-          <p:cNvPr id="7" name="Text 4"/>
+              <a:t>Inline asm</a:t>
+            </a:r>
+            <a:endParaRPr lang="en-US" sz="1200" dirty="0"/>
+          </a:p>
+        </p:txBody>
+      </p:sp>
+      <p:sp>
+        <p:nvSpPr>
+          <p:cNvPr id="9" name="Text 6"/>
           <p:cNvSpPr txBox="1"/>
           <p:nvPr/>
         </p:nvSpPr>
         <p:spPr>
           <a:xfrm>
-            <a:off x="6675120" y="2240280"/>
-            <a:ext cx="2057400" cy="685800"/>
+            <a:off x="7543800" y="2578608"/>
+            <a:ext cx="1115568" cy="749808"/>
           </a:xfrm>
           <a:prstGeom prst="rect">
             <a:avLst/>
@@ -6878,30 +5766,54 @@
               <a:buNone/>
             </a:pPr>
             <a:r>
-              <a:rPr lang="en-US" sz="4000" b="1" dirty="0">
-                <a:solidFill>
-                  <a:schemeClr val="accent3"/>
-                </a:solidFill>
-                <a:latin typeface="Cambria" pitchFamily="34" charset="0"/>
-                <a:ea typeface="Cambria" pitchFamily="34" charset="-122"/>
-                <a:cs typeface="Cambria" pitchFamily="34" charset="-120"/>
+              <a:rPr lang="en-US" sz="1100" dirty="0">
+                <a:solidFill>
+                  <a:schemeClr val="tx2"/>
+                </a:solidFill>
               </a:rPr>
-              <a:t>85–90%</a:t>
-            </a:r>
-            <a:endParaRPr lang="en-US" sz="4000" dirty="0"/>
-          </a:p>
-        </p:txBody>
-      </p:sp>
-      <p:sp>
-        <p:nvSpPr>
-          <p:cNvPr id="8" name="Text 5"/>
+              <a:t>2×6 by hand: 94.5% alone, 84% in layers</a:t>
+            </a:r>
+            <a:endParaRPr lang="en-US" sz="1100" dirty="0"/>
+          </a:p>
+        </p:txBody>
+      </p:sp>
+      <p:sp>
+        <p:nvSpPr>
+          <p:cNvPr id="10" name="ds-card-2"/>
+          <p:cNvSpPr/>
+          <p:nvPr/>
+        </p:nvSpPr>
+        <p:spPr>
+          <a:xfrm>
+            <a:off x="7452360" y="3465576"/>
+            <a:ext cx="1280160" cy="1143000"/>
+          </a:xfrm>
+          <a:prstGeom prst="roundRect">
+            <a:avLst>
+              <a:gd name="adj" fmla="val 6400"/>
+            </a:avLst>
+          </a:prstGeom>
+          <a:solidFill>
+            <a:srgbClr val="EEF2F4"/>
+          </a:solidFill>
+          <a:ln w="12700">
+            <a:solidFill>
+              <a:srgbClr val="EEF2F4"/>
+            </a:solidFill>
+            <a:prstDash val="solid"/>
+          </a:ln>
+        </p:spPr>
+      </p:sp>
+      <p:sp>
+        <p:nvSpPr>
+          <p:cNvPr id="11" name="Text 8"/>
           <p:cNvSpPr txBox="1"/>
           <p:nvPr/>
         </p:nvSpPr>
         <p:spPr>
           <a:xfrm>
-            <a:off x="6675120" y="2953512"/>
-            <a:ext cx="2057400" cy="548640"/>
+            <a:off x="7543800" y="3538728"/>
+            <a:ext cx="1115568" cy="274320"/>
           </a:xfrm>
           <a:prstGeom prst="rect">
             <a:avLst/>
@@ -6917,27 +5829,27 @@
               <a:buNone/>
             </a:pPr>
             <a:r>
-              <a:rPr lang="en-US" sz="1300" dirty="0">
-                <a:solidFill>
-                  <a:schemeClr val="tx2"/>
+              <a:rPr lang="en-US" sz="1200" b="1" dirty="0">
+                <a:solidFill>
+                  <a:schemeClr val="tx1"/>
                 </a:solidFill>
               </a:rPr>
-              <a:t>2×5 intrinsics (v2's tile)</a:t>
-            </a:r>
-            <a:endParaRPr lang="en-US" sz="1300" dirty="0"/>
-          </a:p>
-        </p:txBody>
-      </p:sp>
-      <p:sp>
-        <p:nvSpPr>
-          <p:cNvPr id="9" name="Text 6"/>
+              <a:t>Unroll, pipeline</a:t>
+            </a:r>
+            <a:endParaRPr lang="en-US" sz="1200" dirty="0"/>
+          </a:p>
+        </p:txBody>
+      </p:sp>
+      <p:sp>
+        <p:nvSpPr>
+          <p:cNvPr id="12" name="Text 9"/>
           <p:cNvSpPr txBox="1"/>
           <p:nvPr/>
         </p:nvSpPr>
         <p:spPr>
           <a:xfrm>
-            <a:off x="6675120" y="3520440"/>
-            <a:ext cx="2057400" cy="685800"/>
+            <a:off x="7543800" y="3831336"/>
+            <a:ext cx="1115568" cy="749808"/>
           </a:xfrm>
           <a:prstGeom prst="rect">
             <a:avLst/>
@@ -6953,53 +5865,14 @@
               <a:buNone/>
             </a:pPr>
             <a:r>
-              <a:rPr lang="en-US" sz="4000" b="1" dirty="0">
-                <a:solidFill>
-                  <a:schemeClr val="accent2"/>
-                </a:solidFill>
-                <a:latin typeface="Cambria" pitchFamily="34" charset="0"/>
-                <a:ea typeface="Cambria" pitchFamily="34" charset="-122"/>
-                <a:cs typeface="Cambria" pitchFamily="34" charset="-120"/>
+              <a:rPr lang="en-US" sz="1100" dirty="0">
+                <a:solidFill>
+                  <a:schemeClr val="tx2"/>
+                </a:solidFill>
               </a:rPr>
-              <a:t>k ≈ 500</a:t>
-            </a:r>
-            <a:endParaRPr lang="en-US" sz="4000" dirty="0"/>
-          </a:p>
-        </p:txBody>
-      </p:sp>
-      <p:sp>
-        <p:nvSpPr>
-          <p:cNvPr id="10" name="Text 7"/>
-          <p:cNvSpPr txBox="1"/>
-          <p:nvPr/>
-        </p:nvSpPr>
-        <p:spPr>
-          <a:xfrm>
-            <a:off x="6675120" y="4233672"/>
-            <a:ext cx="2057400" cy="548640"/>
-          </a:xfrm>
-          <a:prstGeom prst="rect">
-            <a:avLst/>
-          </a:prstGeom>
-          <a:noFill/>
-          <a:ln/>
-        </p:spPr>
-        <p:txBody>
-          <a:bodyPr wrap="square" lIns="0" tIns="0" rIns="0" bIns="0" rtlCol="0" anchor="t"/>
-          <a:lstStyle/>
-          <a:p>
-            <a:pPr indent="0" marL="0">
-              <a:buNone/>
-            </a:pPr>
-            <a:r>
-              <a:rPr lang="en-US" sz="1300" dirty="0">
-                <a:solidFill>
-                  <a:schemeClr val="tx2"/>
-                </a:solidFill>
-              </a:rPr>
-              <a:t>L1 dip: 2×5 weights pass 32 KB, like k ≈ 315 in A2</a:t>
-            </a:r>
-            <a:endParaRPr lang="en-US" sz="1300" dirty="0"/>
+              <a:t>lost: uop cache, spills</a:t>
+            </a:r>
+            <a:endParaRPr lang="en-US" sz="1100" dirty="0"/>
           </a:p>
         </p:txBody>
       </p:sp>
@@ -7105,6 +5978,399 @@
                   <a:schemeClr val="tx1"/>
                 </a:solidFill>
               </a:rPr>
+              <a:t>Benchmarked like Assignment 2: FLOPs/cycle vs k</a:t>
+            </a:r>
+            <a:endParaRPr lang="en-US" sz="2600" dirty="0"/>
+          </a:p>
+        </p:txBody>
+      </p:sp>
+      <p:pic>
+        <p:nvPicPr>
+          <p:cNvPr id="3" name="Image 0" descr="FLOPs per cycle vs k for the 2x5, 2x6 and 2x6 asm microkernels with SiLU off">    </p:cNvPr>
+          <p:cNvPicPr>
+            <a:picLocks noChangeAspect="1"/>
+          </p:cNvPicPr>
+          <p:nvPr/>
+        </p:nvPicPr>
+        <p:blipFill>
+          <a:blip r:embed="rId1"/>
+          <a:stretch>
+            <a:fillRect/>
+          </a:stretch>
+        </p:blipFill>
+        <p:spPr>
+          <a:xfrm>
+            <a:off x="457200" y="914400"/>
+            <a:ext cx="5943600" cy="3172968"/>
+          </a:xfrm>
+          <a:prstGeom prst="rect">
+            <a:avLst/>
+          </a:prstGeom>
+        </p:spPr>
+      </p:pic>
+      <p:sp>
+        <p:nvSpPr>
+          <p:cNvPr id="4" name="Text 1"/>
+          <p:cNvSpPr txBox="1"/>
+          <p:nvPr/>
+        </p:nvSpPr>
+        <p:spPr>
+          <a:xfrm>
+            <a:off x="457200" y="4160520"/>
+            <a:ext cx="5943600" cy="457200"/>
+          </a:xfrm>
+          <a:prstGeom prst="rect">
+            <a:avLst/>
+          </a:prstGeom>
+          <a:noFill/>
+          <a:ln/>
+        </p:spPr>
+        <p:txBody>
+          <a:bodyPr wrap="square" lIns="0" tIns="0" rIns="0" bIns="0" rtlCol="0" anchor="t"/>
+          <a:lstStyle/>
+          <a:p>
+            <a:pPr indent="0" marL="0">
+              <a:buNone/>
+            </a:pPr>
+            <a:r>
+              <a:rPr lang="en-US" sz="1200" dirty="0">
+                <a:solidFill>
+                  <a:schemeClr val="tx2"/>
+                </a:solidFill>
+              </a:rPr>
+              <a:t>SiLU off: the pure convolution, as in A2. 3 runs, core cycles, every point checked (576 pass).</a:t>
+            </a:r>
+            <a:endParaRPr lang="en-US" sz="1200" dirty="0"/>
+          </a:p>
+        </p:txBody>
+      </p:sp>
+      <p:sp>
+        <p:nvSpPr>
+          <p:cNvPr id="5" name="Text 2"/>
+          <p:cNvSpPr txBox="1"/>
+          <p:nvPr/>
+        </p:nvSpPr>
+        <p:spPr>
+          <a:xfrm>
+            <a:off x="6675120" y="960120"/>
+            <a:ext cx="2057400" cy="685800"/>
+          </a:xfrm>
+          <a:prstGeom prst="rect">
+            <a:avLst/>
+          </a:prstGeom>
+          <a:noFill/>
+          <a:ln/>
+        </p:spPr>
+        <p:txBody>
+          <a:bodyPr wrap="square" lIns="0" tIns="0" rIns="0" bIns="0" rtlCol="0" anchor="t"/>
+          <a:lstStyle/>
+          <a:p>
+            <a:pPr indent="0" marL="0">
+              <a:buNone/>
+            </a:pPr>
+            <a:r>
+              <a:rPr lang="en-US" sz="4000" b="1" dirty="0">
+                <a:solidFill>
+                  <a:schemeClr val="accent1"/>
+                </a:solidFill>
+                <a:latin typeface="Cambria" pitchFamily="34" charset="0"/>
+                <a:ea typeface="Cambria" pitchFamily="34" charset="-122"/>
+                <a:cs typeface="Cambria" pitchFamily="34" charset="-120"/>
+              </a:rPr>
+              <a:t>94–98%</a:t>
+            </a:r>
+            <a:endParaRPr lang="en-US" sz="4000" dirty="0"/>
+          </a:p>
+        </p:txBody>
+      </p:sp>
+      <p:sp>
+        <p:nvSpPr>
+          <p:cNvPr id="6" name="Text 3"/>
+          <p:cNvSpPr txBox="1"/>
+          <p:nvPr/>
+        </p:nvSpPr>
+        <p:spPr>
+          <a:xfrm>
+            <a:off x="6675120" y="1673352"/>
+            <a:ext cx="2057400" cy="548640"/>
+          </a:xfrm>
+          <a:prstGeom prst="rect">
+            <a:avLst/>
+          </a:prstGeom>
+          <a:noFill/>
+          <a:ln/>
+        </p:spPr>
+        <p:txBody>
+          <a:bodyPr wrap="square" lIns="0" tIns="0" rIns="0" bIns="0" rtlCol="0" anchor="t"/>
+          <a:lstStyle/>
+          <a:p>
+            <a:pPr indent="0" marL="0">
+              <a:buNone/>
+            </a:pPr>
+            <a:r>
+              <a:rPr lang="en-US" sz="1300" dirty="0">
+                <a:solidFill>
+                  <a:schemeClr val="tx2"/>
+                </a:solidFill>
+              </a:rPr>
+              <a:t>2×6 asm: 30–31 FLOPs/cycle, 96 GFLOP/s on one core</a:t>
+            </a:r>
+            <a:endParaRPr lang="en-US" sz="1300" dirty="0"/>
+          </a:p>
+        </p:txBody>
+      </p:sp>
+      <p:sp>
+        <p:nvSpPr>
+          <p:cNvPr id="7" name="Text 4"/>
+          <p:cNvSpPr txBox="1"/>
+          <p:nvPr/>
+        </p:nvSpPr>
+        <p:spPr>
+          <a:xfrm>
+            <a:off x="6675120" y="2240280"/>
+            <a:ext cx="2057400" cy="685800"/>
+          </a:xfrm>
+          <a:prstGeom prst="rect">
+            <a:avLst/>
+          </a:prstGeom>
+          <a:noFill/>
+          <a:ln/>
+        </p:spPr>
+        <p:txBody>
+          <a:bodyPr wrap="square" lIns="0" tIns="0" rIns="0" bIns="0" rtlCol="0" anchor="t"/>
+          <a:lstStyle/>
+          <a:p>
+            <a:pPr indent="0" marL="0">
+              <a:buNone/>
+            </a:pPr>
+            <a:r>
+              <a:rPr lang="en-US" sz="4000" b="1" dirty="0">
+                <a:solidFill>
+                  <a:schemeClr val="accent3"/>
+                </a:solidFill>
+                <a:latin typeface="Cambria" pitchFamily="34" charset="0"/>
+                <a:ea typeface="Cambria" pitchFamily="34" charset="-122"/>
+                <a:cs typeface="Cambria" pitchFamily="34" charset="-120"/>
+              </a:rPr>
+              <a:t>85–90%</a:t>
+            </a:r>
+            <a:endParaRPr lang="en-US" sz="4000" dirty="0"/>
+          </a:p>
+        </p:txBody>
+      </p:sp>
+      <p:sp>
+        <p:nvSpPr>
+          <p:cNvPr id="8" name="Text 5"/>
+          <p:cNvSpPr txBox="1"/>
+          <p:nvPr/>
+        </p:nvSpPr>
+        <p:spPr>
+          <a:xfrm>
+            <a:off x="6675120" y="2953512"/>
+            <a:ext cx="2057400" cy="548640"/>
+          </a:xfrm>
+          <a:prstGeom prst="rect">
+            <a:avLst/>
+          </a:prstGeom>
+          <a:noFill/>
+          <a:ln/>
+        </p:spPr>
+        <p:txBody>
+          <a:bodyPr wrap="square" lIns="0" tIns="0" rIns="0" bIns="0" rtlCol="0" anchor="t"/>
+          <a:lstStyle/>
+          <a:p>
+            <a:pPr indent="0" marL="0">
+              <a:buNone/>
+            </a:pPr>
+            <a:r>
+              <a:rPr lang="en-US" sz="1300" dirty="0">
+                <a:solidFill>
+                  <a:schemeClr val="tx2"/>
+                </a:solidFill>
+              </a:rPr>
+              <a:t>2×5 intrinsics (v2's tile)</a:t>
+            </a:r>
+            <a:endParaRPr lang="en-US" sz="1300" dirty="0"/>
+          </a:p>
+        </p:txBody>
+      </p:sp>
+      <p:sp>
+        <p:nvSpPr>
+          <p:cNvPr id="9" name="Text 6"/>
+          <p:cNvSpPr txBox="1"/>
+          <p:nvPr/>
+        </p:nvSpPr>
+        <p:spPr>
+          <a:xfrm>
+            <a:off x="6675120" y="3520440"/>
+            <a:ext cx="2057400" cy="685800"/>
+          </a:xfrm>
+          <a:prstGeom prst="rect">
+            <a:avLst/>
+          </a:prstGeom>
+          <a:noFill/>
+          <a:ln/>
+        </p:spPr>
+        <p:txBody>
+          <a:bodyPr wrap="square" lIns="0" tIns="0" rIns="0" bIns="0" rtlCol="0" anchor="t"/>
+          <a:lstStyle/>
+          <a:p>
+            <a:pPr indent="0" marL="0">
+              <a:buNone/>
+            </a:pPr>
+            <a:r>
+              <a:rPr lang="en-US" sz="4000" b="1" dirty="0">
+                <a:solidFill>
+                  <a:schemeClr val="accent2"/>
+                </a:solidFill>
+                <a:latin typeface="Cambria" pitchFamily="34" charset="0"/>
+                <a:ea typeface="Cambria" pitchFamily="34" charset="-122"/>
+                <a:cs typeface="Cambria" pitchFamily="34" charset="-120"/>
+              </a:rPr>
+              <a:t>k ≈ 500</a:t>
+            </a:r>
+            <a:endParaRPr lang="en-US" sz="4000" dirty="0"/>
+          </a:p>
+        </p:txBody>
+      </p:sp>
+      <p:sp>
+        <p:nvSpPr>
+          <p:cNvPr id="10" name="Text 7"/>
+          <p:cNvSpPr txBox="1"/>
+          <p:nvPr/>
+        </p:nvSpPr>
+        <p:spPr>
+          <a:xfrm>
+            <a:off x="6675120" y="4233672"/>
+            <a:ext cx="2057400" cy="548640"/>
+          </a:xfrm>
+          <a:prstGeom prst="rect">
+            <a:avLst/>
+          </a:prstGeom>
+          <a:noFill/>
+          <a:ln/>
+        </p:spPr>
+        <p:txBody>
+          <a:bodyPr wrap="square" lIns="0" tIns="0" rIns="0" bIns="0" rtlCol="0" anchor="t"/>
+          <a:lstStyle/>
+          <a:p>
+            <a:pPr indent="0" marL="0">
+              <a:buNone/>
+            </a:pPr>
+            <a:r>
+              <a:rPr lang="en-US" sz="1300" dirty="0">
+                <a:solidFill>
+                  <a:schemeClr val="tx2"/>
+                </a:solidFill>
+              </a:rPr>
+              <a:t>L1 dip: 2×5 weights pass 32 KB, like k ≈ 315 in A2</a:t>
+            </a:r>
+            <a:endParaRPr lang="en-US" sz="1300" dirty="0"/>
+          </a:p>
+        </p:txBody>
+      </p:sp>
+      <p:sp>
+        <p:nvSpPr>
+          <p:cNvPr id="25" name="Slide Number Placeholder 0"/>
+          <p:cNvSpPr>
+            <a:spLocks noGrp="1"/>
+          </p:cNvSpPr>
+          <p:nvPr>
+            <p:ph type="sldNum" sz="quarter" idx="4294967295"/>
+          </p:nvPr>
+        </p:nvSpPr>
+        <p:spPr>
+          <a:xfrm>
+            <a:off x="8229600" y="4800600"/>
+            <a:ext cx="457200" cy="228600"/>
+          </a:xfrm>
+          <a:prstGeom prst="rect">
+            <a:avLst/>
+          </a:prstGeom>
+          <a:extLst>
+            <a:ext uri="{C572A759-6A51-4108-AA02-DFA0A04FC94B}">
+              <ma14:wrappingTextBoxFlag xmlns:ma14="http://schemas.microsoft.com/office/mac/drawingml/2011/main" val="0"/>
+            </a:ext>
+          </a:extLst>
+        </p:spPr>
+        <p:txBody>
+          <a:bodyPr/>
+          <a:lstStyle>
+            <a:lvl1pPr>
+              <a:defRPr sz="1000">
+                <a:solidFill>
+                  <a:srgbClr val="5A6875"/>
+                </a:solidFill>
+              </a:defRPr>
+            </a:lvl1pPr>
+          </a:lstStyle>
+          <a:p>
+            <a:pPr algn="r"/>
+            <a:fld id="{F7021451-1387-4CA6-816F-3879F97B5CBC}" type="slidenum">
+              <a:rPr b="0" lang="en-US"/>
+              <a:t>6</a:t>
+            </a:fld>
+            <a:endParaRPr lang="en-US"/>
+          </a:p>
+        </p:txBody>
+      </p:sp>
+    </p:spTree>
+  </p:cSld>
+  <p:clrMapOvr>
+    <a:masterClrMapping/>
+  </p:clrMapOvr>
+</p:sld>
+</file>
+
+<file path=ppt/slides/slide7.xml><?xml version="1.0" encoding="utf-8"?>
+<p:sld xmlns:a="http://schemas.openxmlformats.org/drawingml/2006/main" xmlns:r="http://schemas.openxmlformats.org/officeDocument/2006/relationships" xmlns:p="http://schemas.openxmlformats.org/presentationml/2006/main">
+  <p:cSld name="Slide 7">
+    <p:spTree>
+      <p:nvGrpSpPr>
+        <p:cNvPr id="1" name=""/>
+        <p:cNvGrpSpPr/>
+        <p:nvPr/>
+      </p:nvGrpSpPr>
+      <p:grpSpPr>
+        <a:xfrm>
+          <a:off x="0" y="0"/>
+          <a:ext cx="0" cy="0"/>
+          <a:chOff x="0" y="0"/>
+          <a:chExt cx="0" cy="0"/>
+        </a:xfrm>
+      </p:grpSpPr>
+      <p:sp>
+        <p:nvSpPr>
+          <p:cNvPr id="2" name="Text 0"/>
+          <p:cNvSpPr/>
+          <p:nvPr>
+            <p:ph idx="100" type="title" hasCustomPrompt="1"/>
+          </p:nvPr>
+        </p:nvSpPr>
+        <p:spPr>
+          <a:xfrm>
+            <a:off x="457200" y="256032"/>
+            <a:ext cx="8229600" cy="640080"/>
+          </a:xfrm>
+          <a:prstGeom prst="rect">
+            <a:avLst/>
+          </a:prstGeom>
+          <a:noFill/>
+          <a:ln/>
+        </p:spPr>
+        <p:txBody>
+          <a:bodyPr wrap="square" lIns="0" tIns="0" rIns="0" bIns="0" rtlCol="0" anchor="ctr"/>
+          <a:lstStyle/>
+          <a:p>
+            <a:pPr algn="l" indent="0" marL="0">
+              <a:buNone/>
+            </a:pPr>
+            <a:r>
+              <a:rPr lang="en-US" sz="2600" b="1" dirty="0">
+                <a:solidFill>
+                  <a:schemeClr val="tx1"/>
+                </a:solidFill>
+              </a:rPr>
               <a:t>Alone vs in a layer: keep the kernel a function</a:t>
             </a:r>
             <a:endParaRPr lang="en-US" sz="2600" dirty="0"/>
@@ -7374,7 +6640,7 @@
             <a:pPr algn="r"/>
             <a:fld id="{F7021451-1387-4CA6-816F-3879F97B5CBC}" type="slidenum">
               <a:rPr b="0" lang="en-US"/>
-              <a:t>6</a:t>
+              <a:t>7</a:t>
             </a:fld>
             <a:endParaRPr lang="en-US"/>
           </a:p>

</xml_diff>

<commit_message>
Om deck + figures at a fixed 3.4 GHz (Assignment 2 convention); fix bench_ukr trial-length comment
Co-Authored-By: Claude Opus 5.5 <noreply@anthropic.com>
Claude-Session: https://claude.ai/code/session_01AeVaHM9UcLNRWUmMTDhqz2
</commit_message>
<xml_diff>
--- a/docs/milestone/om/slides/om_mid_presentation.pptx
+++ b/docs/milestone/om/slides/om_mid_presentation.pptx
@@ -113,19 +113,19 @@
   <p:extLst>
     <p:ext uri="{521415D9-36F7-43E2-AB2F-B90AF26B5E84}">
       <p14:sectionLst xmlns:p14="http://schemas.microsoft.com/office/powerpoint/2010/main">
-        <p14:section name="Intro" id="{cc0f6be9-b7b3-fc0e-4545-2378d9700c8e}">
+        <p14:section name="Intro" id="{5f07b7eb-0e7b-cb5d-4a15-77965b84445b}">
           <p14:sldIdLst>
             <p14:sldId id="256"/>
           </p14:sldIdLst>
         </p14:section>
-        <p14:section name="Method" id="{c5a1c77a-29a8-b51b-7f16-31a5da34ae49}">
+        <p14:section name="Method" id="{9ca9b560-0e06-faf6-e82d-d2d4ef89bae6}">
           <p14:sldIdLst>
             <p14:sldId id="257"/>
             <p14:sldId id="258"/>
             <p14:sldId id="259"/>
           </p14:sldIdLst>
         </p14:section>
-        <p14:section name="Results" id="{7b78a160-273f-887b-f5da-1e61c89234f7}">
+        <p14:section name="Results" id="{c964e5ea-44a2-570b-8a8e-44d4b4a9a973}">
           <p14:sldIdLst>
             <p14:sldId id="260"/>
             <p14:sldId id="261"/>
@@ -262,22 +262,22 @@
                 <c:formatCode>General</c:formatCode>
                 <c:ptCount val="6"/>
                 <c:pt idx="0">
-                  <c:v>10.1</c:v>
+                  <c:v>9.9</c:v>
                 </c:pt>
                 <c:pt idx="1">
-                  <c:v>39.4</c:v>
+                  <c:v>39.3</c:v>
                 </c:pt>
                 <c:pt idx="2">
-                  <c:v>49.9</c:v>
+                  <c:v>49.6</c:v>
                 </c:pt>
                 <c:pt idx="3">
                   <c:v>72.4</c:v>
                 </c:pt>
                 <c:pt idx="4">
-                  <c:v>84</c:v>
+                  <c:v>85.8</c:v>
                 </c:pt>
                 <c:pt idx="5">
-                  <c:v>84.4</c:v>
+                  <c:v>85.3</c:v>
                 </c:pt>
               </c:numCache>
             </c:numRef>
@@ -1129,7 +1129,7 @@
           <a:p>
             <a:r>
               <a:rPr lang="en-US" dirty="0"/>
-              <a:t>My kernel is the 3x3 stride-1 convolution: 32 layers, the C2f bottlenecks and the Detect head, two thirds of YOLOv8n's work. The story: it is the Assignment 2 kernel, I followed the same four steps, and the measurements chose the tile. Best microkernel alone: 94% of the 32 FLOPs/cycle peak; inside all 32 real layers: 84%.</a:t>
+              <a:t>My kernel is the 3x3 stride-1 convolution: 32 layers, the C2f bottlenecks and the Detect head, two thirds of YOLOv8n's work. The story: it is the Assignment 2 kernel, I followed the same four steps, and the measurements chose the tile. Best microkernel alone: 94% of the 32 FLOPs/cycle peak; inside all 32 real layers: 84%. All percentages assume the core runs at 3.4 GHz, as in Assignment 2.</a:t>
             </a:r>
             <a:endParaRPr lang="en-US" dirty="0"/>
           </a:p>
@@ -1481,7 +1481,7 @@
           <a:p>
             <a:r>
               <a:rPr lang="en-US" dirty="0"/>
-              <a:t>Every kernel I built, same arithmetic, same layout. Filled dots are the microkernel alone, hollow are all 32 layers. Left: the accumulator count. Right: the 2x6 tile my teammates suggested loses with intrinsics because GCC adds 11 register copies per tap at 15 live registers, but with the registers fixed in inline asm it is the best kernel, 94.5% alone. 4x3 needs all 16 registers; GCC spills it to 49%. The lecture techniques, unrolling and software pipelining, made it worse: full unrolling overflowed the uop cache and partial unrolling made GCC spill.</a:t>
+              <a:t>Every kernel I built, same arithmetic, same layout. Filled dots are the microkernel alone, hollow are all 32 layers. Left: the accumulator count. Right: the 2x6 tile my teammates suggested loses with intrinsics because GCC adds 11 register copies per tap at 15 live registers, but with the registers fixed in inline asm it is the best kernel, 95% alone. 4x3 needs all 16 registers; GCC spills it to 49%. The lecture techniques, unrolling and software pipelining, made it worse: full unrolling overflowed the uop cache and partial unrolling made GCC spill.</a:t>
             </a:r>
             <a:endParaRPr lang="en-US" dirty="0"/>
           </a:p>
@@ -1569,7 +1569,7 @@
           <a:p>
             <a:r>
               <a:rPr lang="en-US" dirty="0"/>
-              <a:t>This is the Assignment 2 figure for my kernel: FLOPs per cycle against the reduction length k. 2x6 asm holds 30 to 31 FLOPs per cycle, 94 to 98 percent of peak. 2x5 intrinsics is 85 to 90. The dip near k = 500 is the 2x5 weights leaving L1, the same effect as k = 315 in A2. Cross-checked: the hardware FP-instruction counter matches our FLOP count exactly, and cycles over wall time gives 3.2 GHz.</a:t>
+              <a:t>This is the Assignment 2 figure for my kernel: FLOPs per cycle against the reduction length k. Cycles are time times 3.4 GHz, the max turbo, exactly as in Assignment 2, so this can only understate. 2x6 asm holds 30 to 31 FLOPs per cycle, 94 to 97 percent of peak. 2x5 intrinsics is 83 to 89. The dip near k = 500 is the 2x5 weights leaving L1, the same effect as k = 315 in A2. Cross-checked: the hardware FP-instruction counter matches our FLOP count exactly, and real perf cycles give the same or slightly higher numbers.</a:t>
             </a:r>
             <a:endParaRPr lang="en-US" dirty="0"/>
           </a:p>
@@ -1657,7 +1657,7 @@
           <a:p>
             <a:r>
               <a:rPr lang="en-US" dirty="0"/>
-              <a:t>Kernel A, 2x5 in asm, beat kernel B, 2x5 intrinsics, by 6 points alone but lost by 3.5 in the layers. The assembly shows why: inlined into the layer loop, GCC keeps 3 accumulators on the stack and reloads them around every tap. Calling the microkernel as a function, exactly as the benchmark does, fixes it: 83.4% for 2x5 and 84.1% for v10. v10 is 1.36 times faster than OpenCV and within 2% of ONNX Runtime on all 32 layers. Next: cache blocking and threading.</a:t>
+              <a:t>Kernel A, 2x5 in asm, beat kernel B, 2x5 intrinsics, by 7 points alone but lost by 4 in the layers. The assembly shows why: inlined into the layer loop, GCC keeps 3 accumulators on the stack and reloads them around every tap. Calling the microkernel as a function, exactly as the benchmark does, fixes it: 83.1% for 2x5 and 83.7% for v10, all at 3.4 GHz. v10 is 1.36 times faster than OpenCV and within 2% of ONNX Runtime on all 32 layers. Next: cache blocking and threading.</a:t>
             </a:r>
             <a:endParaRPr lang="en-US" dirty="0"/>
           </a:p>
@@ -5425,7 +5425,7 @@
                   <a:schemeClr val="tx2"/>
                 </a:solidFill>
               </a:rPr>
-              <a:t>Microkernel alone, k = 72 to 4608, 3 runs, 2 s warm-up, core cycles, checked vs a reference.</a:t>
+              <a:t>Microkernel alone, k = 72 to 4608, 3 runs, 2 s warm-up, cycles at 3.4 GHz as in A2, checked vs a reference.</a:t>
             </a:r>
             <a:endParaRPr lang="en-US" sz="1200" dirty="0"/>
           </a:p>
@@ -5771,7 +5771,7 @@
                   <a:schemeClr val="tx2"/>
                 </a:solidFill>
               </a:rPr>
-              <a:t>2×6 by hand: 94.5% alone, 84% in layers</a:t>
+              <a:t>2×6 by hand: 95% alone, 84% in layers</a:t>
             </a:r>
             <a:endParaRPr lang="en-US" sz="1100" dirty="0"/>
           </a:p>
@@ -6038,7 +6038,7 @@
                   <a:schemeClr val="tx2"/>
                 </a:solidFill>
               </a:rPr>
-              <a:t>SiLU off: the pure convolution, as in A2. 3 runs, core cycles, every point checked (576 pass).</a:t>
+              <a:t>SiLU off, cycles = time × 3.4 GHz, as in A2. 3 runs, every point checked (576 pass).</a:t>
             </a:r>
             <a:endParaRPr lang="en-US" sz="1200" dirty="0"/>
           </a:p>
@@ -6077,7 +6077,7 @@
                 <a:ea typeface="Cambria" pitchFamily="34" charset="-122"/>
                 <a:cs typeface="Cambria" pitchFamily="34" charset="-120"/>
               </a:rPr>
-              <a:t>94–98%</a:t>
+              <a:t>94–97%</a:t>
             </a:r>
             <a:endParaRPr lang="en-US" sz="4000" dirty="0"/>
           </a:p>
@@ -6113,7 +6113,7 @@
                   <a:schemeClr val="tx2"/>
                 </a:solidFill>
               </a:rPr>
-              <a:t>2×6 asm: 30–31 FLOPs/cycle, 96 GFLOP/s on one core</a:t>
+              <a:t>2×6 asm: 30–31 FLOPs/cycle, ~102 GFLOP/s on one core</a:t>
             </a:r>
             <a:endParaRPr lang="en-US" sz="1300" dirty="0"/>
           </a:p>
@@ -6152,7 +6152,7 @@
                 <a:ea typeface="Cambria" pitchFamily="34" charset="-122"/>
                 <a:cs typeface="Cambria" pitchFamily="34" charset="-120"/>
               </a:rPr>
-              <a:t>85–90%</a:t>
+              <a:t>83–89%</a:t>
             </a:r>
             <a:endParaRPr lang="en-US" sz="4000" dirty="0"/>
           </a:p>
@@ -6407,7 +6407,7 @@
                   <a:schemeClr val="tx1"/>
                 </a:solidFill>
               </a:rPr>
-              <a:t>v2a (2×5 asm): 90.2% alone, 73.6% when GCC inlines it into the layer loop</a:t>
+              <a:t>v2a (2×5 asm): 92.2% alone, 72.5% when GCC inlines it into the layer loop</a:t>
             </a:r>
             <a:endParaRPr lang="en-US" sz="1400" dirty="0"/>
           </a:p>
@@ -6543,7 +6543,7 @@
                   <a:schemeClr val="tx2"/>
                 </a:solidFill>
               </a:rPr>
-              <a:t>Inlined, GCC keeps 3 of 10 accumulators on the stack around every tap. Called as a function, as in the benchmark: 83.4% (v2b); with the 2×6 tile, 84.1% (v10).</a:t>
+              <a:t>Inlined, GCC keeps 3 of 10 accumulators on the stack around every tap. Called as a function, as in the benchmark: 83.1% (v2b); with the 2×6 tile, 83.7% (v10).</a:t>
             </a:r>
             <a:endParaRPr lang="en-US" sz="1300" dirty="0"/>
           </a:p>

</xml_diff>